<commit_message>
Updating sections of PowerPoint
</commit_message>
<xml_diff>
--- a/615_781_Kuta_Nguyen_McLain.pptx
+++ b/615_781_Kuta_Nguyen_McLain.pptx
@@ -199,6 +199,83 @@
     </pc:docChg>
   </pc:docChgLst>
   <pc:docChgLst>
+    <pc:chgData name="Uyen P. Nguyen" userId="S::unguyen7@jh.edu::92021b55-417f-458a-90a7-cf14ced67da3" providerId="AD" clId="Web-{1C5DA43F-1144-560B-A996-9F9957834AF2}"/>
+    <pc:docChg chg="modSld">
+      <pc:chgData name="Uyen P. Nguyen" userId="S::unguyen7@jh.edu::92021b55-417f-458a-90a7-cf14ced67da3" providerId="AD" clId="Web-{1C5DA43F-1144-560B-A996-9F9957834AF2}" dt="2026-05-03T01:28:46.789" v="180" actId="20577"/>
+      <pc:docMkLst>
+        <pc:docMk/>
+      </pc:docMkLst>
+      <pc:sldChg chg="modSp">
+        <pc:chgData name="Uyen P. Nguyen" userId="S::unguyen7@jh.edu::92021b55-417f-458a-90a7-cf14ced67da3" providerId="AD" clId="Web-{1C5DA43F-1144-560B-A996-9F9957834AF2}" dt="2026-05-03T01:28:46.789" v="180" actId="20577"/>
+        <pc:sldMkLst>
+          <pc:docMk/>
+          <pc:sldMk cId="2133178391" sldId="257"/>
+        </pc:sldMkLst>
+        <pc:spChg chg="mod">
+          <ac:chgData name="Uyen P. Nguyen" userId="S::unguyen7@jh.edu::92021b55-417f-458a-90a7-cf14ced67da3" providerId="AD" clId="Web-{1C5DA43F-1144-560B-A996-9F9957834AF2}" dt="2026-05-03T00:49:04.439" v="76" actId="20577"/>
+          <ac:spMkLst>
+            <pc:docMk/>
+            <pc:sldMk cId="2133178391" sldId="257"/>
+            <ac:spMk id="7" creationId="{D159B653-A360-6E33-D2F6-A0D58B9935A5}"/>
+          </ac:spMkLst>
+        </pc:spChg>
+        <pc:spChg chg="mod">
+          <ac:chgData name="Uyen P. Nguyen" userId="S::unguyen7@jh.edu::92021b55-417f-458a-90a7-cf14ced67da3" providerId="AD" clId="Web-{1C5DA43F-1144-560B-A996-9F9957834AF2}" dt="2026-05-03T01:28:46.789" v="180" actId="20577"/>
+          <ac:spMkLst>
+            <pc:docMk/>
+            <pc:sldMk cId="2133178391" sldId="257"/>
+            <ac:spMk id="9" creationId="{EABC739E-24F8-66FD-A37D-4CF4952DF00F}"/>
+          </ac:spMkLst>
+        </pc:spChg>
+      </pc:sldChg>
+      <pc:sldChg chg="modSp">
+        <pc:chgData name="Uyen P. Nguyen" userId="S::unguyen7@jh.edu::92021b55-417f-458a-90a7-cf14ced67da3" providerId="AD" clId="Web-{1C5DA43F-1144-560B-A996-9F9957834AF2}" dt="2026-05-03T00:49:00.532" v="72" actId="20577"/>
+        <pc:sldMkLst>
+          <pc:docMk/>
+          <pc:sldMk cId="1284274485" sldId="259"/>
+        </pc:sldMkLst>
+        <pc:spChg chg="mod">
+          <ac:chgData name="Uyen P. Nguyen" userId="S::unguyen7@jh.edu::92021b55-417f-458a-90a7-cf14ced67da3" providerId="AD" clId="Web-{1C5DA43F-1144-560B-A996-9F9957834AF2}" dt="2026-05-03T00:49:00.532" v="72" actId="20577"/>
+          <ac:spMkLst>
+            <pc:docMk/>
+            <pc:sldMk cId="1284274485" sldId="259"/>
+            <ac:spMk id="7" creationId="{32741F24-76C7-9C01-1DBD-5EE3762FAACA}"/>
+          </ac:spMkLst>
+        </pc:spChg>
+      </pc:sldChg>
+      <pc:sldChg chg="modSp">
+        <pc:chgData name="Uyen P. Nguyen" userId="S::unguyen7@jh.edu::92021b55-417f-458a-90a7-cf14ced67da3" providerId="AD" clId="Web-{1C5DA43F-1144-560B-A996-9F9957834AF2}" dt="2026-05-03T00:48:55.797" v="67" actId="20577"/>
+        <pc:sldMkLst>
+          <pc:docMk/>
+          <pc:sldMk cId="1027488440" sldId="260"/>
+        </pc:sldMkLst>
+        <pc:spChg chg="mod">
+          <ac:chgData name="Uyen P. Nguyen" userId="S::unguyen7@jh.edu::92021b55-417f-458a-90a7-cf14ced67da3" providerId="AD" clId="Web-{1C5DA43F-1144-560B-A996-9F9957834AF2}" dt="2026-05-03T00:48:55.797" v="67" actId="20577"/>
+          <ac:spMkLst>
+            <pc:docMk/>
+            <pc:sldMk cId="1027488440" sldId="260"/>
+            <ac:spMk id="7" creationId="{2C42AF74-C537-A886-53B7-E8DF3240B7B7}"/>
+          </ac:spMkLst>
+        </pc:spChg>
+      </pc:sldChg>
+      <pc:sldChg chg="modSp">
+        <pc:chgData name="Uyen P. Nguyen" userId="S::unguyen7@jh.edu::92021b55-417f-458a-90a7-cf14ced67da3" providerId="AD" clId="Web-{1C5DA43F-1144-560B-A996-9F9957834AF2}" dt="2026-05-03T00:46:37.606" v="25"/>
+        <pc:sldMkLst>
+          <pc:docMk/>
+          <pc:sldMk cId="2092433718" sldId="265"/>
+        </pc:sldMkLst>
+        <pc:graphicFrameChg chg="mod modGraphic">
+          <ac:chgData name="Uyen P. Nguyen" userId="S::unguyen7@jh.edu::92021b55-417f-458a-90a7-cf14ced67da3" providerId="AD" clId="Web-{1C5DA43F-1144-560B-A996-9F9957834AF2}" dt="2026-05-03T00:46:37.606" v="25"/>
+          <ac:graphicFrameMkLst>
+            <pc:docMk/>
+            <pc:sldMk cId="2092433718" sldId="265"/>
+            <ac:graphicFrameMk id="3" creationId="{15498308-56C6-0976-7133-85BE4FA98101}"/>
+          </ac:graphicFrameMkLst>
+        </pc:graphicFrameChg>
+      </pc:sldChg>
+    </pc:docChg>
+  </pc:docChgLst>
+  <pc:docChgLst>
     <pc:chgData name="Uyen P. Nguyen" userId="S::unguyen7@jh.edu::92021b55-417f-458a-90a7-cf14ced67da3" providerId="AD" clId="Web-{C8FECEF0-CD1E-8A61-D6A9-E78BD7F5FC65}"/>
     <pc:docChg chg="addSld modSld sldOrd">
       <pc:chgData name="Uyen P. Nguyen" userId="S::unguyen7@jh.edu::92021b55-417f-458a-90a7-cf14ced67da3" providerId="AD" clId="Web-{C8FECEF0-CD1E-8A61-D6A9-E78BD7F5FC65}" dt="2026-05-03T02:56:56.270" v="1241" actId="20577"/>
@@ -382,83 +459,6 @@
             <ac:picMk id="8" creationId="{B38A110A-4554-DD53-7B39-D305EC31083C}"/>
           </ac:picMkLst>
         </pc:picChg>
-      </pc:sldChg>
-    </pc:docChg>
-  </pc:docChgLst>
-  <pc:docChgLst>
-    <pc:chgData name="Uyen P. Nguyen" userId="S::unguyen7@jh.edu::92021b55-417f-458a-90a7-cf14ced67da3" providerId="AD" clId="Web-{1C5DA43F-1144-560B-A996-9F9957834AF2}"/>
-    <pc:docChg chg="modSld">
-      <pc:chgData name="Uyen P. Nguyen" userId="S::unguyen7@jh.edu::92021b55-417f-458a-90a7-cf14ced67da3" providerId="AD" clId="Web-{1C5DA43F-1144-560B-A996-9F9957834AF2}" dt="2026-05-03T01:28:46.789" v="180" actId="20577"/>
-      <pc:docMkLst>
-        <pc:docMk/>
-      </pc:docMkLst>
-      <pc:sldChg chg="modSp">
-        <pc:chgData name="Uyen P. Nguyen" userId="S::unguyen7@jh.edu::92021b55-417f-458a-90a7-cf14ced67da3" providerId="AD" clId="Web-{1C5DA43F-1144-560B-A996-9F9957834AF2}" dt="2026-05-03T01:28:46.789" v="180" actId="20577"/>
-        <pc:sldMkLst>
-          <pc:docMk/>
-          <pc:sldMk cId="2133178391" sldId="257"/>
-        </pc:sldMkLst>
-        <pc:spChg chg="mod">
-          <ac:chgData name="Uyen P. Nguyen" userId="S::unguyen7@jh.edu::92021b55-417f-458a-90a7-cf14ced67da3" providerId="AD" clId="Web-{1C5DA43F-1144-560B-A996-9F9957834AF2}" dt="2026-05-03T00:49:04.439" v="76" actId="20577"/>
-          <ac:spMkLst>
-            <pc:docMk/>
-            <pc:sldMk cId="2133178391" sldId="257"/>
-            <ac:spMk id="7" creationId="{D159B653-A360-6E33-D2F6-A0D58B9935A5}"/>
-          </ac:spMkLst>
-        </pc:spChg>
-        <pc:spChg chg="mod">
-          <ac:chgData name="Uyen P. Nguyen" userId="S::unguyen7@jh.edu::92021b55-417f-458a-90a7-cf14ced67da3" providerId="AD" clId="Web-{1C5DA43F-1144-560B-A996-9F9957834AF2}" dt="2026-05-03T01:28:46.789" v="180" actId="20577"/>
-          <ac:spMkLst>
-            <pc:docMk/>
-            <pc:sldMk cId="2133178391" sldId="257"/>
-            <ac:spMk id="9" creationId="{EABC739E-24F8-66FD-A37D-4CF4952DF00F}"/>
-          </ac:spMkLst>
-        </pc:spChg>
-      </pc:sldChg>
-      <pc:sldChg chg="modSp">
-        <pc:chgData name="Uyen P. Nguyen" userId="S::unguyen7@jh.edu::92021b55-417f-458a-90a7-cf14ced67da3" providerId="AD" clId="Web-{1C5DA43F-1144-560B-A996-9F9957834AF2}" dt="2026-05-03T00:49:00.532" v="72" actId="20577"/>
-        <pc:sldMkLst>
-          <pc:docMk/>
-          <pc:sldMk cId="1284274485" sldId="259"/>
-        </pc:sldMkLst>
-        <pc:spChg chg="mod">
-          <ac:chgData name="Uyen P. Nguyen" userId="S::unguyen7@jh.edu::92021b55-417f-458a-90a7-cf14ced67da3" providerId="AD" clId="Web-{1C5DA43F-1144-560B-A996-9F9957834AF2}" dt="2026-05-03T00:49:00.532" v="72" actId="20577"/>
-          <ac:spMkLst>
-            <pc:docMk/>
-            <pc:sldMk cId="1284274485" sldId="259"/>
-            <ac:spMk id="7" creationId="{32741F24-76C7-9C01-1DBD-5EE3762FAACA}"/>
-          </ac:spMkLst>
-        </pc:spChg>
-      </pc:sldChg>
-      <pc:sldChg chg="modSp">
-        <pc:chgData name="Uyen P. Nguyen" userId="S::unguyen7@jh.edu::92021b55-417f-458a-90a7-cf14ced67da3" providerId="AD" clId="Web-{1C5DA43F-1144-560B-A996-9F9957834AF2}" dt="2026-05-03T00:48:55.797" v="67" actId="20577"/>
-        <pc:sldMkLst>
-          <pc:docMk/>
-          <pc:sldMk cId="1027488440" sldId="260"/>
-        </pc:sldMkLst>
-        <pc:spChg chg="mod">
-          <ac:chgData name="Uyen P. Nguyen" userId="S::unguyen7@jh.edu::92021b55-417f-458a-90a7-cf14ced67da3" providerId="AD" clId="Web-{1C5DA43F-1144-560B-A996-9F9957834AF2}" dt="2026-05-03T00:48:55.797" v="67" actId="20577"/>
-          <ac:spMkLst>
-            <pc:docMk/>
-            <pc:sldMk cId="1027488440" sldId="260"/>
-            <ac:spMk id="7" creationId="{2C42AF74-C537-A886-53B7-E8DF3240B7B7}"/>
-          </ac:spMkLst>
-        </pc:spChg>
-      </pc:sldChg>
-      <pc:sldChg chg="modSp">
-        <pc:chgData name="Uyen P. Nguyen" userId="S::unguyen7@jh.edu::92021b55-417f-458a-90a7-cf14ced67da3" providerId="AD" clId="Web-{1C5DA43F-1144-560B-A996-9F9957834AF2}" dt="2026-05-03T00:46:37.606" v="25"/>
-        <pc:sldMkLst>
-          <pc:docMk/>
-          <pc:sldMk cId="2092433718" sldId="265"/>
-        </pc:sldMkLst>
-        <pc:graphicFrameChg chg="mod modGraphic">
-          <ac:chgData name="Uyen P. Nguyen" userId="S::unguyen7@jh.edu::92021b55-417f-458a-90a7-cf14ced67da3" providerId="AD" clId="Web-{1C5DA43F-1144-560B-A996-9F9957834AF2}" dt="2026-05-03T00:46:37.606" v="25"/>
-          <ac:graphicFrameMkLst>
-            <pc:docMk/>
-            <pc:sldMk cId="2092433718" sldId="265"/>
-            <ac:graphicFrameMk id="3" creationId="{15498308-56C6-0976-7133-85BE4FA98101}"/>
-          </ac:graphicFrameMkLst>
-        </pc:graphicFrameChg>
       </pc:sldChg>
     </pc:docChg>
   </pc:docChgLst>
@@ -1058,7 +1058,7 @@
           <a:p>
             <a:fld id="{35653055-CE3A-8142-A33E-C797CCF22D71}" type="datetimeFigureOut">
               <a:rPr lang="en-US" smtClean="0"/>
-              <a:t>5/2/2026</a:t>
+              <a:t>5/3/2026</a:t>
             </a:fld>
             <a:endParaRPr lang="en-US"/>
           </a:p>
@@ -1256,7 +1256,7 @@
           <a:p>
             <a:fld id="{35653055-CE3A-8142-A33E-C797CCF22D71}" type="datetimeFigureOut">
               <a:rPr lang="en-US" smtClean="0"/>
-              <a:t>5/2/2026</a:t>
+              <a:t>5/3/2026</a:t>
             </a:fld>
             <a:endParaRPr lang="en-US"/>
           </a:p>
@@ -1464,7 +1464,7 @@
           <a:p>
             <a:fld id="{35653055-CE3A-8142-A33E-C797CCF22D71}" type="datetimeFigureOut">
               <a:rPr lang="en-US" smtClean="0"/>
-              <a:t>5/2/2026</a:t>
+              <a:t>5/3/2026</a:t>
             </a:fld>
             <a:endParaRPr lang="en-US"/>
           </a:p>
@@ -1662,7 +1662,7 @@
           <a:p>
             <a:fld id="{35653055-CE3A-8142-A33E-C797CCF22D71}" type="datetimeFigureOut">
               <a:rPr lang="en-US" smtClean="0"/>
-              <a:t>5/2/2026</a:t>
+              <a:t>5/3/2026</a:t>
             </a:fld>
             <a:endParaRPr lang="en-US"/>
           </a:p>
@@ -1937,7 +1937,7 @@
           <a:p>
             <a:fld id="{35653055-CE3A-8142-A33E-C797CCF22D71}" type="datetimeFigureOut">
               <a:rPr lang="en-US" smtClean="0"/>
-              <a:t>5/2/2026</a:t>
+              <a:t>5/3/2026</a:t>
             </a:fld>
             <a:endParaRPr lang="en-US"/>
           </a:p>
@@ -2202,7 +2202,7 @@
           <a:p>
             <a:fld id="{35653055-CE3A-8142-A33E-C797CCF22D71}" type="datetimeFigureOut">
               <a:rPr lang="en-US" smtClean="0"/>
-              <a:t>5/2/2026</a:t>
+              <a:t>5/3/2026</a:t>
             </a:fld>
             <a:endParaRPr lang="en-US"/>
           </a:p>
@@ -2614,7 +2614,7 @@
           <a:p>
             <a:fld id="{35653055-CE3A-8142-A33E-C797CCF22D71}" type="datetimeFigureOut">
               <a:rPr lang="en-US" smtClean="0"/>
-              <a:t>5/2/2026</a:t>
+              <a:t>5/3/2026</a:t>
             </a:fld>
             <a:endParaRPr lang="en-US"/>
           </a:p>
@@ -2755,7 +2755,7 @@
           <a:p>
             <a:fld id="{35653055-CE3A-8142-A33E-C797CCF22D71}" type="datetimeFigureOut">
               <a:rPr lang="en-US" smtClean="0"/>
-              <a:t>5/2/2026</a:t>
+              <a:t>5/3/2026</a:t>
             </a:fld>
             <a:endParaRPr lang="en-US"/>
           </a:p>
@@ -2868,7 +2868,7 @@
           <a:p>
             <a:fld id="{35653055-CE3A-8142-A33E-C797CCF22D71}" type="datetimeFigureOut">
               <a:rPr lang="en-US" smtClean="0"/>
-              <a:t>5/2/2026</a:t>
+              <a:t>5/3/2026</a:t>
             </a:fld>
             <a:endParaRPr lang="en-US"/>
           </a:p>
@@ -3179,7 +3179,7 @@
           <a:p>
             <a:fld id="{35653055-CE3A-8142-A33E-C797CCF22D71}" type="datetimeFigureOut">
               <a:rPr lang="en-US" smtClean="0"/>
-              <a:t>5/2/2026</a:t>
+              <a:t>5/3/2026</a:t>
             </a:fld>
             <a:endParaRPr lang="en-US"/>
           </a:p>
@@ -3467,7 +3467,7 @@
           <a:p>
             <a:fld id="{35653055-CE3A-8142-A33E-C797CCF22D71}" type="datetimeFigureOut">
               <a:rPr lang="en-US" smtClean="0"/>
-              <a:t>5/2/2026</a:t>
+              <a:t>5/3/2026</a:t>
             </a:fld>
             <a:endParaRPr lang="en-US"/>
           </a:p>
@@ -3708,7 +3708,7 @@
           <a:p>
             <a:fld id="{35653055-CE3A-8142-A33E-C797CCF22D71}" type="datetimeFigureOut">
               <a:rPr lang="en-US" smtClean="0"/>
-              <a:t>5/2/2026</a:t>
+              <a:t>5/3/2026</a:t>
             </a:fld>
             <a:endParaRPr lang="en-US"/>
           </a:p>
@@ -4471,230 +4471,399 @@
           </a:p>
         </p:txBody>
       </p:sp>
-      <p:sp>
-        <p:nvSpPr>
-          <p:cNvPr id="9" name="TextBox 8">
-            <a:extLst>
-              <a:ext uri="{FF2B5EF4-FFF2-40B4-BE49-F238E27FC236}">
-                <a16:creationId xmlns:a16="http://schemas.microsoft.com/office/drawing/2014/main" id="{B508FDDF-3951-0564-B047-DD35ABA722F0}"/>
-              </a:ext>
-            </a:extLst>
-          </p:cNvPr>
-          <p:cNvSpPr txBox="1"/>
-          <p:nvPr/>
-        </p:nvSpPr>
-        <p:spPr>
-          <a:xfrm>
-            <a:off x="457200" y="1181100"/>
-            <a:ext cx="10590028" cy="3154710"/>
-          </a:xfrm>
-          <a:prstGeom prst="rect">
-            <a:avLst/>
-          </a:prstGeom>
-          <a:noFill/>
-        </p:spPr>
-        <p:txBody>
-          <a:bodyPr wrap="square" lIns="91440" tIns="45720" rIns="91440" bIns="45720" anchor="t">
-            <a:spAutoFit/>
-          </a:bodyPr>
-          <a:lstStyle/>
-          <a:p>
-            <a:pPr marL="285750" indent="-285750">
-              <a:buFont typeface="Arial" panose="020B0604020202020204" pitchFamily="34" charset="0"/>
-              <a:buChar char="•"/>
-            </a:pPr>
-            <a:r>
-              <a:rPr lang="en-US" sz="2000">
-                <a:solidFill>
-                  <a:srgbClr val="202123"/>
-                </a:solidFill>
-                <a:latin typeface="Calibri"/>
-                <a:ea typeface="Calibri"/>
-                <a:cs typeface="Calibri"/>
-              </a:rPr>
-              <a:t>After achieving a sifted key, how do we know it is correct?</a:t>
-            </a:r>
-            <a:endParaRPr lang="en-US" sz="2000">
-              <a:solidFill>
-                <a:srgbClr val="202123"/>
-              </a:solidFill>
-              <a:latin typeface="Calibri" panose="020F0502020204030204" pitchFamily="34" charset="0"/>
-              <a:cs typeface="Calibri" panose="020F0502020204030204" pitchFamily="34" charset="0"/>
-            </a:endParaRPr>
-          </a:p>
-          <a:p>
-            <a:pPr marL="742950" lvl="1" indent="-285750">
-              <a:buFont typeface="Courier New" panose="020B0604020202020204" pitchFamily="34" charset="0"/>
-              <a:buChar char="o"/>
-            </a:pPr>
-            <a:r>
-              <a:rPr lang="en-US" sz="2000">
-                <a:solidFill>
-                  <a:srgbClr val="202123"/>
-                </a:solidFill>
-                <a:latin typeface="Calibri"/>
-                <a:ea typeface="Calibri"/>
-                <a:cs typeface="Calibri"/>
-              </a:rPr>
-              <a:t>Cascade Procedure</a:t>
-            </a:r>
-          </a:p>
-          <a:p>
-            <a:pPr marL="1200150" lvl="2" indent="-285750">
-              <a:buFont typeface="Wingdings" panose="020B0604020202020204" pitchFamily="34" charset="0"/>
-              <a:buChar char="§"/>
-            </a:pPr>
-            <a:r>
-              <a:rPr lang="en-US" sz="2000">
-                <a:solidFill>
-                  <a:srgbClr val="202123"/>
-                </a:solidFill>
-                <a:latin typeface="Calibri"/>
-                <a:ea typeface="Calibri"/>
-                <a:cs typeface="Calibri"/>
-              </a:rPr>
-              <a:t>Divide the key into blocks and perform a parity check on each block</a:t>
-            </a:r>
-          </a:p>
-          <a:p>
-            <a:pPr marL="1657350" lvl="3" indent="-285750">
-              <a:buFont typeface="Arial" panose="020B0604020202020204" pitchFamily="34" charset="0"/>
-              <a:buChar char="•"/>
-            </a:pPr>
-            <a:r>
-              <a:rPr lang="en-US" sz="2000">
-                <a:solidFill>
-                  <a:srgbClr val="202123"/>
-                </a:solidFill>
-                <a:latin typeface="Calibri"/>
-                <a:ea typeface="Calibri"/>
-                <a:cs typeface="Calibri"/>
-              </a:rPr>
-              <a:t>Iterate over any mismatches in parity (binary search) to find error(s)</a:t>
-            </a:r>
-          </a:p>
-          <a:p>
-            <a:pPr marL="1200150" lvl="2" indent="-285750">
-              <a:buFont typeface="Wingdings" panose="020B0604020202020204" pitchFamily="34" charset="0"/>
-              <a:buChar char="§"/>
-            </a:pPr>
-            <a:r>
-              <a:rPr lang="en-US" sz="2000">
-                <a:solidFill>
-                  <a:srgbClr val="202123"/>
-                </a:solidFill>
-                <a:latin typeface="Calibri"/>
-                <a:ea typeface="Calibri"/>
-                <a:cs typeface="Calibri"/>
-              </a:rPr>
-              <a:t>Permute the bits and repeat</a:t>
-            </a:r>
-          </a:p>
-          <a:p>
-            <a:pPr marL="742950" lvl="1" indent="-285750">
-              <a:buFont typeface="Courier New" panose="020B0604020202020204" pitchFamily="34" charset="0"/>
-              <a:buChar char="o"/>
-            </a:pPr>
-            <a:r>
-              <a:rPr lang="en-US" sz="2000">
-                <a:solidFill>
-                  <a:srgbClr val="202123"/>
-                </a:solidFill>
-                <a:latin typeface="Calibri"/>
-                <a:ea typeface="Calibri"/>
-                <a:cs typeface="Calibri"/>
-              </a:rPr>
-              <a:t>Only requires communication over a public channel</a:t>
-            </a:r>
-          </a:p>
-          <a:p>
-            <a:pPr marL="285750" indent="-285750">
-              <a:spcBef>
-                <a:spcPts val="600"/>
-              </a:spcBef>
-              <a:buFont typeface="Arial" panose="020B0604020202020204" pitchFamily="34" charset="0"/>
-              <a:buChar char="•"/>
-            </a:pPr>
-            <a:r>
-              <a:rPr lang="en-US" sz="2000">
-                <a:solidFill>
-                  <a:srgbClr val="202123"/>
-                </a:solidFill>
-                <a:latin typeface="Calibri" panose="020F0502020204030204" pitchFamily="34" charset="0"/>
-                <a:cs typeface="Calibri" panose="020F0502020204030204" pitchFamily="34" charset="0"/>
-              </a:rPr>
-              <a:t>Results:</a:t>
-            </a:r>
-          </a:p>
-          <a:p>
-            <a:pPr marL="742950" lvl="1" indent="-285750">
-              <a:buFont typeface="Courier New" panose="02070309020205020404" pitchFamily="49" charset="0"/>
-              <a:buChar char="o"/>
-            </a:pPr>
-            <a:r>
-              <a:rPr lang="en-US">
-                <a:solidFill>
-                  <a:srgbClr val="202123"/>
-                </a:solidFill>
-                <a:latin typeface="Calibri"/>
-                <a:ea typeface="Calibri"/>
-                <a:cs typeface="Calibri"/>
-              </a:rPr>
-              <a:t>Pre-correction QBER: 92% match (59 of 64 bits)</a:t>
-            </a:r>
-            <a:endParaRPr lang="en-US">
-              <a:solidFill>
-                <a:srgbClr val="202123"/>
-              </a:solidFill>
-              <a:latin typeface="Calibri" panose="020F0502020204030204" pitchFamily="34" charset="0"/>
-              <a:ea typeface="Calibri"/>
-              <a:cs typeface="Calibri" panose="020F0502020204030204" pitchFamily="34" charset="0"/>
-            </a:endParaRPr>
-          </a:p>
-          <a:p>
-            <a:pPr marL="742950" lvl="1" indent="-285750">
-              <a:buFont typeface="Courier New" panose="02070309020205020404" pitchFamily="49" charset="0"/>
-              <a:buChar char="o"/>
-            </a:pPr>
-            <a:r>
-              <a:rPr lang="en-US">
-                <a:solidFill>
-                  <a:srgbClr val="202123"/>
-                </a:solidFill>
-                <a:latin typeface="Calibri"/>
-                <a:ea typeface="Calibri"/>
-                <a:cs typeface="Calibri"/>
-              </a:rPr>
-              <a:t>Post-correction QBER: 100% match (64 of 64 bits)</a:t>
-            </a:r>
-          </a:p>
-          <a:p>
-            <a:pPr marL="1200150" lvl="2" indent="-285750">
-              <a:buFont typeface="Wingdings" panose="02070309020205020404" pitchFamily="49" charset="0"/>
-              <a:buChar char="§"/>
-            </a:pPr>
-            <a:r>
-              <a:rPr lang="en-US">
-                <a:solidFill>
-                  <a:srgbClr val="202123"/>
-                </a:solidFill>
-                <a:latin typeface="Calibri"/>
-                <a:ea typeface="Calibri"/>
-                <a:cs typeface="Calibri"/>
-              </a:rPr>
-              <a:t>Up to 5 bits leaked to Eve</a:t>
-            </a:r>
-            <a:endParaRPr lang="en-US" dirty="0">
-              <a:solidFill>
-                <a:srgbClr val="202123"/>
-              </a:solidFill>
-              <a:latin typeface="Calibri" panose="020F0502020204030204" pitchFamily="34" charset="0"/>
-              <a:ea typeface="Calibri"/>
-              <a:cs typeface="Calibri" panose="020F0502020204030204" pitchFamily="34" charset="0"/>
-            </a:endParaRPr>
-          </a:p>
-        </p:txBody>
-      </p:sp>
+      <mc:AlternateContent xmlns:mc="http://schemas.openxmlformats.org/markup-compatibility/2006">
+        <mc:Choice xmlns:a14="http://schemas.microsoft.com/office/drawing/2010/main" Requires="a14">
+          <p:sp>
+            <p:nvSpPr>
+              <p:cNvPr id="9" name="TextBox 8">
+                <a:extLst>
+                  <a:ext uri="{FF2B5EF4-FFF2-40B4-BE49-F238E27FC236}">
+                    <a16:creationId xmlns:a16="http://schemas.microsoft.com/office/drawing/2014/main" id="{B508FDDF-3951-0564-B047-DD35ABA722F0}"/>
+                  </a:ext>
+                </a:extLst>
+              </p:cNvPr>
+              <p:cNvSpPr txBox="1"/>
+              <p:nvPr/>
+            </p:nvSpPr>
+            <p:spPr>
+              <a:xfrm>
+                <a:off x="457200" y="1181100"/>
+                <a:ext cx="10590028" cy="4546116"/>
+              </a:xfrm>
+              <a:prstGeom prst="rect">
+                <a:avLst/>
+              </a:prstGeom>
+              <a:noFill/>
+            </p:spPr>
+            <p:txBody>
+              <a:bodyPr wrap="square" lIns="91440" tIns="45720" rIns="91440" bIns="45720" anchor="t">
+                <a:spAutoFit/>
+              </a:bodyPr>
+              <a:lstStyle/>
+              <a:p>
+                <a:pPr marL="285750" indent="-285750">
+                  <a:buFont typeface="Arial" panose="020B0604020202020204" pitchFamily="34" charset="0"/>
+                  <a:buChar char="•"/>
+                </a:pPr>
+                <a:r>
+                  <a:rPr lang="en-US" sz="2000" dirty="0">
+                    <a:solidFill>
+                      <a:srgbClr val="202123"/>
+                    </a:solidFill>
+                    <a:latin typeface="Calibri"/>
+                    <a:ea typeface="Calibri"/>
+                    <a:cs typeface="Calibri"/>
+                  </a:rPr>
+                  <a:t>After achieving a sifted key, how do we know it is correct?</a:t>
+                </a:r>
+                <a:endParaRPr lang="en-US" sz="2000" dirty="0">
+                  <a:solidFill>
+                    <a:srgbClr val="202123"/>
+                  </a:solidFill>
+                  <a:latin typeface="Calibri" panose="020F0502020204030204" pitchFamily="34" charset="0"/>
+                  <a:cs typeface="Calibri" panose="020F0502020204030204" pitchFamily="34" charset="0"/>
+                </a:endParaRPr>
+              </a:p>
+              <a:p>
+                <a:pPr marL="742950" lvl="1" indent="-285750">
+                  <a:buFont typeface="Courier New" panose="020B0604020202020204" pitchFamily="34" charset="0"/>
+                  <a:buChar char="o"/>
+                </a:pPr>
+                <a:r>
+                  <a:rPr lang="en-US" sz="2000" dirty="0">
+                    <a:solidFill>
+                      <a:srgbClr val="202123"/>
+                    </a:solidFill>
+                    <a:latin typeface="Calibri"/>
+                    <a:ea typeface="Calibri"/>
+                    <a:cs typeface="Calibri"/>
+                  </a:rPr>
+                  <a:t>Cascade Procedure</a:t>
+                </a:r>
+              </a:p>
+              <a:p>
+                <a:pPr marL="1200150" lvl="2" indent="-285750">
+                  <a:buFont typeface="Wingdings" panose="020B0604020202020204" pitchFamily="34" charset="0"/>
+                  <a:buChar char="§"/>
+                </a:pPr>
+                <a:r>
+                  <a:rPr lang="en-US" sz="2000" dirty="0">
+                    <a:solidFill>
+                      <a:srgbClr val="202123"/>
+                    </a:solidFill>
+                    <a:latin typeface="Calibri"/>
+                    <a:ea typeface="Calibri"/>
+                    <a:cs typeface="Calibri"/>
+                  </a:rPr>
+                  <a:t>Divide the key into blocks and perform a parity check on each block</a:t>
+                </a:r>
+              </a:p>
+              <a:p>
+                <a:pPr marL="1657350" lvl="3" indent="-285750">
+                  <a:buFont typeface="Wingdings" panose="020B0604020202020204" pitchFamily="34" charset="0"/>
+                  <a:buChar char="§"/>
+                </a:pPr>
+                <a:r>
+                  <a:rPr lang="en-US" sz="2000" dirty="0">
+                    <a:solidFill>
+                      <a:srgbClr val="202123"/>
+                    </a:solidFill>
+                    <a:latin typeface="Calibri"/>
+                    <a:ea typeface="Calibri"/>
+                    <a:cs typeface="Calibri"/>
+                  </a:rPr>
+                  <a:t>Heuristic for block size:  </a:t>
+                </a:r>
+                <a14:m>
+                  <m:oMath xmlns:m="http://schemas.openxmlformats.org/officeDocument/2006/math">
+                    <m:r>
+                      <a:rPr lang="en-US" sz="2000" b="0" i="1" smtClean="0">
+                        <a:solidFill>
+                          <a:srgbClr val="202123"/>
+                        </a:solidFill>
+                        <a:latin typeface="Cambria Math" panose="02040503050406030204" pitchFamily="18" charset="0"/>
+                        <a:ea typeface="Calibri"/>
+                        <a:cs typeface="Calibri"/>
+                      </a:rPr>
+                      <m:t>≈</m:t>
+                    </m:r>
+                    <m:f>
+                      <m:fPr>
+                        <m:ctrlPr>
+                          <a:rPr lang="en-US" sz="2000" b="0" i="1" smtClean="0">
+                            <a:solidFill>
+                              <a:srgbClr val="202123"/>
+                            </a:solidFill>
+                            <a:latin typeface="Cambria Math" panose="02040503050406030204" pitchFamily="18" charset="0"/>
+                            <a:ea typeface="Calibri"/>
+                            <a:cs typeface="Calibri"/>
+                          </a:rPr>
+                        </m:ctrlPr>
+                      </m:fPr>
+                      <m:num>
+                        <m:r>
+                          <a:rPr lang="en-US" sz="2000" b="0" i="1" smtClean="0">
+                            <a:solidFill>
+                              <a:srgbClr val="202123"/>
+                            </a:solidFill>
+                            <a:latin typeface="Cambria Math" panose="02040503050406030204" pitchFamily="18" charset="0"/>
+                            <a:ea typeface="Calibri"/>
+                            <a:cs typeface="Calibri"/>
+                          </a:rPr>
+                          <m:t>1</m:t>
+                        </m:r>
+                      </m:num>
+                      <m:den>
+                        <m:r>
+                          <a:rPr lang="en-US" sz="2000" b="0" i="1" smtClean="0">
+                            <a:solidFill>
+                              <a:srgbClr val="202123"/>
+                            </a:solidFill>
+                            <a:latin typeface="Cambria Math" panose="02040503050406030204" pitchFamily="18" charset="0"/>
+                            <a:ea typeface="Calibri"/>
+                            <a:cs typeface="Calibri"/>
+                          </a:rPr>
+                          <m:t>𝑄𝐵𝐸𝑅</m:t>
+                        </m:r>
+                      </m:den>
+                    </m:f>
+                  </m:oMath>
+                </a14:m>
+                <a:endParaRPr lang="en-US" sz="2000" dirty="0">
+                  <a:solidFill>
+                    <a:srgbClr val="202123"/>
+                  </a:solidFill>
+                  <a:latin typeface="Calibri"/>
+                  <a:ea typeface="Calibri"/>
+                  <a:cs typeface="Calibri"/>
+                </a:endParaRPr>
+              </a:p>
+              <a:p>
+                <a:pPr marL="1657350" lvl="3" indent="-285750">
+                  <a:buFont typeface="Wingdings" panose="020B0604020202020204" pitchFamily="34" charset="0"/>
+                  <a:buChar char="§"/>
+                </a:pPr>
+                <a:r>
+                  <a:rPr lang="en-US" sz="2000" dirty="0">
+                    <a:solidFill>
+                      <a:srgbClr val="202123"/>
+                    </a:solidFill>
+                    <a:latin typeface="Calibri"/>
+                    <a:ea typeface="Calibri"/>
+                    <a:cs typeface="Calibri"/>
+                  </a:rPr>
+                  <a:t>Iterate over any mismatches in parity (binary search) to find error(s)</a:t>
+                </a:r>
+              </a:p>
+              <a:p>
+                <a:pPr marL="1657350" lvl="3" indent="-285750">
+                  <a:buFont typeface="Wingdings" panose="020B0604020202020204" pitchFamily="34" charset="0"/>
+                  <a:buChar char="§"/>
+                </a:pPr>
+                <a:r>
+                  <a:rPr lang="en-US" sz="2000" dirty="0">
+                    <a:solidFill>
+                      <a:srgbClr val="202123"/>
+                    </a:solidFill>
+                    <a:ea typeface="Calibri"/>
+                    <a:cs typeface="Calibri"/>
+                  </a:rPr>
+                  <a:t>Each parity comparison leaks a bit of information to eavesdropper</a:t>
+                </a:r>
+                <a:endParaRPr lang="en-US" sz="2000" dirty="0">
+                  <a:solidFill>
+                    <a:srgbClr val="202123"/>
+                  </a:solidFill>
+                  <a:latin typeface="Calibri"/>
+                  <a:ea typeface="Calibri"/>
+                  <a:cs typeface="Calibri"/>
+                </a:endParaRPr>
+              </a:p>
+              <a:p>
+                <a:pPr marL="1200150" lvl="2" indent="-285750">
+                  <a:buFont typeface="Wingdings" panose="020B0604020202020204" pitchFamily="34" charset="0"/>
+                  <a:buChar char="§"/>
+                </a:pPr>
+                <a:r>
+                  <a:rPr lang="en-US" sz="2000" dirty="0">
+                    <a:solidFill>
+                      <a:srgbClr val="202123"/>
+                    </a:solidFill>
+                    <a:latin typeface="Calibri"/>
+                    <a:ea typeface="Calibri"/>
+                    <a:cs typeface="Calibri"/>
+                  </a:rPr>
+                  <a:t>Permute the bits and repeat</a:t>
+                </a:r>
+              </a:p>
+              <a:p>
+                <a:pPr marL="1657350" lvl="3" indent="-285750">
+                  <a:buFont typeface="Wingdings" panose="020B0604020202020204" pitchFamily="34" charset="0"/>
+                  <a:buChar char="§"/>
+                </a:pPr>
+                <a:r>
+                  <a:rPr lang="en-US" sz="2000" dirty="0">
+                    <a:solidFill>
+                      <a:srgbClr val="202123"/>
+                    </a:solidFill>
+                    <a:latin typeface="Calibri"/>
+                    <a:ea typeface="Calibri"/>
+                    <a:cs typeface="Calibri"/>
+                  </a:rPr>
+                  <a:t>Increasing the number of permutations resolves more errors but increases information leakage</a:t>
+                </a:r>
+              </a:p>
+              <a:p>
+                <a:pPr marL="742950" lvl="1" indent="-285750">
+                  <a:buFont typeface="Courier New" panose="020B0604020202020204" pitchFamily="34" charset="0"/>
+                  <a:buChar char="o"/>
+                </a:pPr>
+                <a:r>
+                  <a:rPr lang="en-US" sz="2000" dirty="0">
+                    <a:solidFill>
+                      <a:srgbClr val="202123"/>
+                    </a:solidFill>
+                    <a:latin typeface="Calibri"/>
+                    <a:ea typeface="Calibri"/>
+                    <a:cs typeface="Calibri"/>
+                  </a:rPr>
+                  <a:t>Only requires communication over a public channel</a:t>
+                </a:r>
+              </a:p>
+              <a:p>
+                <a:pPr marL="285750" indent="-285750">
+                  <a:spcBef>
+                    <a:spcPts val="600"/>
+                  </a:spcBef>
+                  <a:buFont typeface="Arial" panose="020B0604020202020204" pitchFamily="34" charset="0"/>
+                  <a:buChar char="•"/>
+                </a:pPr>
+                <a:r>
+                  <a:rPr lang="en-US" sz="2000" dirty="0">
+                    <a:solidFill>
+                      <a:srgbClr val="202123"/>
+                    </a:solidFill>
+                    <a:latin typeface="Calibri" panose="020F0502020204030204" pitchFamily="34" charset="0"/>
+                    <a:cs typeface="Calibri" panose="020F0502020204030204" pitchFamily="34" charset="0"/>
+                  </a:rPr>
+                  <a:t>Results:</a:t>
+                </a:r>
+              </a:p>
+              <a:p>
+                <a:pPr marL="742950" lvl="1" indent="-285750">
+                  <a:buFont typeface="Courier New" panose="02070309020205020404" pitchFamily="49" charset="0"/>
+                  <a:buChar char="o"/>
+                </a:pPr>
+                <a:r>
+                  <a:rPr lang="en-US" dirty="0">
+                    <a:solidFill>
+                      <a:srgbClr val="202123"/>
+                    </a:solidFill>
+                    <a:latin typeface="Calibri"/>
+                    <a:ea typeface="Calibri"/>
+                    <a:cs typeface="Calibri"/>
+                  </a:rPr>
+                  <a:t>Pre-correction QBER: 92% match (59 of 64 bits)</a:t>
+                </a:r>
+                <a:endParaRPr lang="en-US" dirty="0">
+                  <a:solidFill>
+                    <a:srgbClr val="202123"/>
+                  </a:solidFill>
+                  <a:latin typeface="Calibri" panose="020F0502020204030204" pitchFamily="34" charset="0"/>
+                  <a:ea typeface="Calibri"/>
+                  <a:cs typeface="Calibri" panose="020F0502020204030204" pitchFamily="34" charset="0"/>
+                </a:endParaRPr>
+              </a:p>
+              <a:p>
+                <a:pPr marL="742950" lvl="1" indent="-285750">
+                  <a:buFont typeface="Courier New" panose="02070309020205020404" pitchFamily="49" charset="0"/>
+                  <a:buChar char="o"/>
+                </a:pPr>
+                <a:r>
+                  <a:rPr lang="en-US" dirty="0">
+                    <a:solidFill>
+                      <a:srgbClr val="202123"/>
+                    </a:solidFill>
+                    <a:latin typeface="Calibri"/>
+                    <a:ea typeface="Calibri"/>
+                    <a:cs typeface="Calibri"/>
+                  </a:rPr>
+                  <a:t>Post-correction QBER: 100% match (64 of 64 bits)</a:t>
+                </a:r>
+              </a:p>
+              <a:p>
+                <a:pPr marL="1200150" lvl="2" indent="-285750">
+                  <a:buFont typeface="Wingdings" panose="02070309020205020404" pitchFamily="49" charset="0"/>
+                  <a:buChar char="§"/>
+                </a:pPr>
+                <a:r>
+                  <a:rPr lang="en-US" dirty="0">
+                    <a:solidFill>
+                      <a:srgbClr val="202123"/>
+                    </a:solidFill>
+                    <a:latin typeface="Calibri"/>
+                    <a:ea typeface="Calibri"/>
+                    <a:cs typeface="Calibri"/>
+                  </a:rPr>
+                  <a:t>Up to 5 bits leaked to Eve</a:t>
+                </a:r>
+                <a:endParaRPr lang="en-US" dirty="0">
+                  <a:solidFill>
+                    <a:srgbClr val="202123"/>
+                  </a:solidFill>
+                  <a:latin typeface="Calibri" panose="020F0502020204030204" pitchFamily="34" charset="0"/>
+                  <a:ea typeface="Calibri"/>
+                  <a:cs typeface="Calibri" panose="020F0502020204030204" pitchFamily="34" charset="0"/>
+                </a:endParaRPr>
+              </a:p>
+            </p:txBody>
+          </p:sp>
+        </mc:Choice>
+        <mc:Fallback>
+          <p:sp>
+            <p:nvSpPr>
+              <p:cNvPr id="9" name="TextBox 8">
+                <a:extLst>
+                  <a:ext uri="{FF2B5EF4-FFF2-40B4-BE49-F238E27FC236}">
+                    <a16:creationId xmlns:a16="http://schemas.microsoft.com/office/drawing/2014/main" id="{B508FDDF-3951-0564-B047-DD35ABA722F0}"/>
+                  </a:ext>
+                </a:extLst>
+              </p:cNvPr>
+              <p:cNvSpPr txBox="1">
+                <a:spLocks noRot="1" noChangeAspect="1" noMove="1" noResize="1" noEditPoints="1" noAdjustHandles="1" noChangeArrowheads="1" noChangeShapeType="1" noTextEdit="1"/>
+              </p:cNvSpPr>
+              <p:nvPr/>
+            </p:nvSpPr>
+            <p:spPr>
+              <a:xfrm>
+                <a:off x="457200" y="1181100"/>
+                <a:ext cx="10590028" cy="4546116"/>
+              </a:xfrm>
+              <a:prstGeom prst="rect">
+                <a:avLst/>
+              </a:prstGeom>
+              <a:blipFill>
+                <a:blip r:embed="rId2"/>
+                <a:stretch>
+                  <a:fillRect l="-518" t="-804" b="-1206"/>
+                </a:stretch>
+              </a:blipFill>
+            </p:spPr>
+            <p:txBody>
+              <a:bodyPr/>
+              <a:lstStyle/>
+              <a:p>
+                <a:r>
+                  <a:rPr lang="en-US">
+                    <a:noFill/>
+                  </a:rPr>
+                  <a:t> </a:t>
+                </a:r>
+              </a:p>
+            </p:txBody>
+          </p:sp>
+        </mc:Fallback>
+      </mc:AlternateContent>
     </p:spTree>
     <p:extLst>
       <p:ext uri="{BB962C8B-B14F-4D97-AF65-F5344CB8AC3E}">
@@ -4815,246 +4984,470 @@
           </a:p>
         </p:txBody>
       </p:sp>
-      <p:sp>
-        <p:nvSpPr>
-          <p:cNvPr id="9" name="TextBox 8">
-            <a:extLst>
-              <a:ext uri="{FF2B5EF4-FFF2-40B4-BE49-F238E27FC236}">
-                <a16:creationId xmlns:a16="http://schemas.microsoft.com/office/drawing/2014/main" id="{F5F91DD6-6252-5987-ED81-0F61A3E07FAE}"/>
-              </a:ext>
-            </a:extLst>
-          </p:cNvPr>
-          <p:cNvSpPr txBox="1"/>
-          <p:nvPr/>
-        </p:nvSpPr>
-        <p:spPr>
-          <a:xfrm>
-            <a:off x="457200" y="1181100"/>
-            <a:ext cx="10590028" cy="3539430"/>
-          </a:xfrm>
-          <a:prstGeom prst="rect">
-            <a:avLst/>
-          </a:prstGeom>
-          <a:noFill/>
-        </p:spPr>
-        <p:txBody>
-          <a:bodyPr wrap="square" lIns="91440" tIns="45720" rIns="91440" bIns="45720" anchor="t">
-            <a:spAutoFit/>
-          </a:bodyPr>
-          <a:lstStyle/>
-          <a:p>
-            <a:pPr marL="285750" indent="-285750">
-              <a:buFont typeface="Arial" panose="020B0604020202020204" pitchFamily="34" charset="0"/>
-              <a:buChar char="•"/>
-            </a:pPr>
-            <a:r>
-              <a:rPr lang="en-US" sz="2000">
-                <a:solidFill>
-                  <a:srgbClr val="202123"/>
-                </a:solidFill>
-                <a:latin typeface="Calibri"/>
-                <a:ea typeface="Calibri"/>
-                <a:cs typeface="Calibri"/>
-              </a:rPr>
-              <a:t>What will be amplified? Eve's mutual information with Alice and Bob</a:t>
-            </a:r>
-            <a:endParaRPr lang="en-US"/>
-          </a:p>
-          <a:p>
-            <a:pPr marL="285750" indent="-285750">
-              <a:buFont typeface="Arial" panose="020B0604020202020204" pitchFamily="34" charset="0"/>
-              <a:buChar char="•"/>
-            </a:pPr>
-            <a:r>
-              <a:rPr lang="en-US" sz="2000">
-                <a:solidFill>
-                  <a:srgbClr val="202123"/>
-                </a:solidFill>
-                <a:latin typeface="Calibri"/>
-                <a:ea typeface="Calibri"/>
-                <a:cs typeface="Calibri"/>
-              </a:rPr>
-              <a:t>By what method? Hashing</a:t>
-            </a:r>
-            <a:endParaRPr lang="en-US"/>
-          </a:p>
-          <a:p>
-            <a:pPr marL="742950" lvl="1" indent="-285750">
-              <a:buFont typeface="Courier New" panose="020B0604020202020204" pitchFamily="34" charset="0"/>
-              <a:buChar char="o"/>
-            </a:pPr>
-            <a:r>
-              <a:rPr lang="en-US" sz="2000">
-                <a:solidFill>
-                  <a:srgbClr val="202123"/>
-                </a:solidFill>
-                <a:latin typeface="Calibri"/>
-                <a:ea typeface="Calibri"/>
-                <a:cs typeface="Calibri"/>
-              </a:rPr>
-              <a:t>Toeplitz matrix</a:t>
-            </a:r>
-            <a:endParaRPr lang="en-US" sz="2000" dirty="0">
-              <a:solidFill>
-                <a:srgbClr val="202123"/>
-              </a:solidFill>
-              <a:latin typeface="Calibri"/>
-              <a:ea typeface="Calibri"/>
-              <a:cs typeface="Calibri"/>
-            </a:endParaRPr>
-          </a:p>
-          <a:p>
-            <a:pPr marL="285750" indent="-285750">
-              <a:buFont typeface="Arial" panose="020B0604020202020204" pitchFamily="34" charset="0"/>
-              <a:buChar char="•"/>
-            </a:pPr>
-            <a:r>
-              <a:rPr lang="en-US" sz="2000">
-                <a:solidFill>
-                  <a:srgbClr val="202123"/>
-                </a:solidFill>
-                <a:latin typeface="Calibri" panose="020F0502020204030204" pitchFamily="34" charset="0"/>
-                <a:cs typeface="Calibri" panose="020F0502020204030204" pitchFamily="34" charset="0"/>
-              </a:rPr>
-              <a:t>Results:</a:t>
-            </a:r>
-          </a:p>
-          <a:p>
-            <a:pPr marL="742950" lvl="1" indent="-285750">
-              <a:buFont typeface="Courier New" panose="02070309020205020404" pitchFamily="49" charset="0"/>
-              <a:buChar char="o"/>
-            </a:pPr>
-            <a:r>
-              <a:rPr lang="en-US" dirty="0">
-                <a:solidFill>
-                  <a:srgbClr val="202123"/>
-                </a:solidFill>
-                <a:latin typeface="Calibri"/>
-                <a:ea typeface="Calibri"/>
-                <a:cs typeface="Calibri"/>
-              </a:rPr>
-              <a:t>Instead of a 64-bit key where Eve has 5 sets of parity checks, we have 39 bits of private information</a:t>
-            </a:r>
-          </a:p>
-          <a:p>
-            <a:pPr marL="742950" lvl="1" indent="-285750">
-              <a:buFont typeface="Courier New" panose="02070309020205020404" pitchFamily="49" charset="0"/>
-              <a:buChar char="o"/>
-            </a:pPr>
-            <a:r>
-              <a:rPr lang="en-US">
-                <a:solidFill>
-                  <a:srgbClr val="202123"/>
-                </a:solidFill>
-                <a:latin typeface="Calibri"/>
-                <a:ea typeface="Calibri"/>
-                <a:cs typeface="Calibri"/>
-              </a:rPr>
-              <a:t>A shorter but more secure key</a:t>
-            </a:r>
-          </a:p>
-          <a:p>
-            <a:pPr marL="742950" lvl="1" indent="-285750">
-              <a:buFont typeface="Courier New" panose="02070309020205020404" pitchFamily="49" charset="0"/>
-              <a:buChar char="o"/>
-            </a:pPr>
-            <a:endParaRPr lang="en-US" dirty="0">
-              <a:solidFill>
-                <a:srgbClr val="202123"/>
-              </a:solidFill>
-              <a:latin typeface="Calibri" panose="020F0502020204030204" pitchFamily="34" charset="0"/>
-              <a:ea typeface="Calibri"/>
-              <a:cs typeface="Calibri" panose="020F0502020204030204" pitchFamily="34" charset="0"/>
-            </a:endParaRPr>
-          </a:p>
-          <a:p>
-            <a:pPr marL="742950" lvl="1" indent="-285750">
-              <a:buFont typeface="Courier New" panose="02070309020205020404" pitchFamily="49" charset="0"/>
-              <a:buChar char="o"/>
-            </a:pPr>
-            <a:r>
-              <a:rPr lang="en-US">
-                <a:solidFill>
-                  <a:srgbClr val="202123"/>
-                </a:solidFill>
-                <a:latin typeface="Calibri"/>
-                <a:ea typeface="Calibri"/>
-                <a:cs typeface="Calibri"/>
-              </a:rPr>
-              <a:t>Example:</a:t>
-            </a:r>
-            <a:endParaRPr lang="en-US" dirty="0">
-              <a:solidFill>
-                <a:srgbClr val="202123"/>
-              </a:solidFill>
-              <a:latin typeface="Calibri" panose="020F0502020204030204" pitchFamily="34" charset="0"/>
-              <a:ea typeface="Calibri"/>
-              <a:cs typeface="Calibri" panose="020F0502020204030204" pitchFamily="34" charset="0"/>
-            </a:endParaRPr>
-          </a:p>
-          <a:p>
-            <a:pPr marL="1200150" lvl="2" indent="-285750">
-              <a:buFont typeface="Wingdings" panose="02070309020205020404" pitchFamily="49" charset="0"/>
-              <a:buChar char="§"/>
-            </a:pPr>
-            <a:r>
-              <a:rPr lang="en-US">
-                <a:solidFill>
-                  <a:srgbClr val="202123"/>
-                </a:solidFill>
-                <a:ea typeface="+mn-lt"/>
-                <a:cs typeface="+mn-lt"/>
-              </a:rPr>
-              <a:t>To encode "BB84"</a:t>
-            </a:r>
-            <a:endParaRPr lang="en-US" dirty="0">
-              <a:solidFill>
-                <a:srgbClr val="202123"/>
-              </a:solidFill>
-              <a:ea typeface="+mn-lt"/>
-              <a:cs typeface="+mn-lt"/>
-            </a:endParaRPr>
-          </a:p>
-          <a:p>
-            <a:pPr lvl="2"/>
-            <a:r>
-              <a:rPr lang="en-US">
-                <a:solidFill>
-                  <a:srgbClr val="202123"/>
-                </a:solidFill>
-                <a:ea typeface="+mn-lt"/>
-                <a:cs typeface="+mn-lt"/>
-              </a:rPr>
-              <a:t>Key:  11110111001101011111011010111100</a:t>
-            </a:r>
-          </a:p>
-          <a:p>
-            <a:pPr lvl="2"/>
-            <a:r>
-              <a:rPr lang="en-US"/>
-              <a:t>Cipher Text: 11001111101011000101001111011001</a:t>
-            </a:r>
-          </a:p>
-          <a:p>
-            <a:pPr lvl="2"/>
-            <a:r>
-              <a:rPr lang="en-US">
-                <a:ea typeface="Calibri" panose="020F0502020204030204"/>
-                <a:cs typeface="Calibri" panose="020F0502020204030204"/>
-              </a:rPr>
-              <a:t>Decoded: </a:t>
-            </a:r>
-            <a:r>
-              <a:rPr lang="en-US">
-                <a:ea typeface="+mn-lt"/>
-                <a:cs typeface="+mn-lt"/>
-              </a:rPr>
-              <a:t>00000000010000100000100000000010</a:t>
-            </a:r>
-            <a:endParaRPr lang="en-US"/>
-          </a:p>
-        </p:txBody>
-      </p:sp>
+      <mc:AlternateContent xmlns:mc="http://schemas.openxmlformats.org/markup-compatibility/2006">
+        <mc:Choice xmlns:a14="http://schemas.microsoft.com/office/drawing/2010/main" Requires="a14">
+          <p:sp>
+            <p:nvSpPr>
+              <p:cNvPr id="9" name="TextBox 8">
+                <a:extLst>
+                  <a:ext uri="{FF2B5EF4-FFF2-40B4-BE49-F238E27FC236}">
+                    <a16:creationId xmlns:a16="http://schemas.microsoft.com/office/drawing/2014/main" id="{F5F91DD6-6252-5987-ED81-0F61A3E07FAE}"/>
+                  </a:ext>
+                </a:extLst>
+              </p:cNvPr>
+              <p:cNvSpPr txBox="1"/>
+              <p:nvPr/>
+            </p:nvSpPr>
+            <p:spPr>
+              <a:xfrm>
+                <a:off x="457200" y="1181100"/>
+                <a:ext cx="10590028" cy="4731552"/>
+              </a:xfrm>
+              <a:prstGeom prst="rect">
+                <a:avLst/>
+              </a:prstGeom>
+              <a:noFill/>
+            </p:spPr>
+            <p:txBody>
+              <a:bodyPr wrap="square" lIns="91440" tIns="45720" rIns="91440" bIns="45720" anchor="t">
+                <a:spAutoFit/>
+              </a:bodyPr>
+              <a:lstStyle/>
+              <a:p>
+                <a:pPr marL="285750" indent="-285750">
+                  <a:buFont typeface="Arial" panose="020B0604020202020204" pitchFamily="34" charset="0"/>
+                  <a:buChar char="•"/>
+                </a:pPr>
+                <a:r>
+                  <a:rPr lang="en-US" sz="2000" dirty="0">
+                    <a:solidFill>
+                      <a:srgbClr val="202123"/>
+                    </a:solidFill>
+                    <a:latin typeface="Calibri"/>
+                    <a:ea typeface="Calibri"/>
+                    <a:cs typeface="Calibri"/>
+                  </a:rPr>
+                  <a:t>What will be amplified? Eve's mutual information with Alice and Bob</a:t>
+                </a:r>
+              </a:p>
+              <a:p>
+                <a:pPr marL="285750" indent="-285750">
+                  <a:buFont typeface="Arial" panose="020B0604020202020204" pitchFamily="34" charset="0"/>
+                  <a:buChar char="•"/>
+                </a:pPr>
+                <a:r>
+                  <a:rPr lang="en-US" dirty="0"/>
+                  <a:t>Compress length </a:t>
+                </a:r>
+                <a:r>
+                  <a:rPr lang="en-US" i="1" dirty="0"/>
+                  <a:t>n</a:t>
+                </a:r>
+                <a:r>
+                  <a:rPr lang="en-US" dirty="0"/>
+                  <a:t> bit string to length </a:t>
+                </a:r>
+                <a:r>
+                  <a:rPr lang="en-US" i="1" dirty="0"/>
+                  <a:t>m </a:t>
+                </a:r>
+                <a:r>
+                  <a:rPr lang="en-US" dirty="0"/>
+                  <a:t>bit string to maximize entropy</a:t>
+                </a:r>
+              </a:p>
+              <a:p>
+                <a:pPr marL="742950" lvl="1" indent="-285750">
+                  <a:buFont typeface="Arial" panose="020B0604020202020204" pitchFamily="34" charset="0"/>
+                  <a:buChar char="•"/>
+                </a:pPr>
+                <a14:m>
+                  <m:oMath xmlns:m="http://schemas.openxmlformats.org/officeDocument/2006/math">
+                    <m:r>
+                      <a:rPr lang="en-US" b="0" i="1" smtClean="0">
+                        <a:latin typeface="Cambria Math" panose="02040503050406030204" pitchFamily="18" charset="0"/>
+                      </a:rPr>
+                      <m:t>𝑚</m:t>
+                    </m:r>
+                    <m:r>
+                      <a:rPr lang="en-US" b="0" i="1" smtClean="0">
+                        <a:latin typeface="Cambria Math" panose="02040503050406030204" pitchFamily="18" charset="0"/>
+                      </a:rPr>
+                      <m:t>≈</m:t>
+                    </m:r>
+                    <m:r>
+                      <a:rPr lang="en-US" b="0" i="1" smtClean="0">
+                        <a:latin typeface="Cambria Math" panose="02040503050406030204" pitchFamily="18" charset="0"/>
+                      </a:rPr>
+                      <m:t>𝑛</m:t>
+                    </m:r>
+                    <m:r>
+                      <a:rPr lang="en-US" b="0" i="1" smtClean="0">
+                        <a:latin typeface="Cambria Math" panose="02040503050406030204" pitchFamily="18" charset="0"/>
+                      </a:rPr>
+                      <m:t> −</m:t>
+                    </m:r>
+                    <m:r>
+                      <a:rPr lang="en-US" b="0" i="1" smtClean="0">
+                        <a:latin typeface="Cambria Math" panose="02040503050406030204" pitchFamily="18" charset="0"/>
+                      </a:rPr>
+                      <m:t>𝐸𝑣</m:t>
+                    </m:r>
+                    <m:sSub>
+                      <m:sSubPr>
+                        <m:ctrlPr>
+                          <a:rPr lang="en-US" b="0" i="1" smtClean="0">
+                            <a:latin typeface="Cambria Math" panose="02040503050406030204" pitchFamily="18" charset="0"/>
+                          </a:rPr>
+                        </m:ctrlPr>
+                      </m:sSubPr>
+                      <m:e>
+                        <m:r>
+                          <a:rPr lang="en-US" b="0" i="1" smtClean="0">
+                            <a:latin typeface="Cambria Math" panose="02040503050406030204" pitchFamily="18" charset="0"/>
+                          </a:rPr>
+                          <m:t>𝑒</m:t>
+                        </m:r>
+                      </m:e>
+                      <m:sub>
+                        <m:r>
+                          <a:rPr lang="en-US" b="0" i="1" smtClean="0">
+                            <a:latin typeface="Cambria Math" panose="02040503050406030204" pitchFamily="18" charset="0"/>
+                          </a:rPr>
+                          <m:t>𝑖𝑛𝑓𝑜</m:t>
+                        </m:r>
+                      </m:sub>
+                    </m:sSub>
+                    <m:r>
+                      <a:rPr lang="en-US" b="0" i="1" smtClean="0">
+                        <a:latin typeface="Cambria Math" panose="02040503050406030204" pitchFamily="18" charset="0"/>
+                      </a:rPr>
+                      <m:t>−</m:t>
+                    </m:r>
+                    <m:r>
+                      <a:rPr lang="en-US" b="0" i="1" smtClean="0">
+                        <a:latin typeface="Cambria Math" panose="02040503050406030204" pitchFamily="18" charset="0"/>
+                      </a:rPr>
+                      <m:t>𝑠𝑒𝑐𝑢𝑟𝑖𝑡</m:t>
+                    </m:r>
+                    <m:sSub>
+                      <m:sSubPr>
+                        <m:ctrlPr>
+                          <a:rPr lang="en-US" b="0" i="1" smtClean="0">
+                            <a:latin typeface="Cambria Math" panose="02040503050406030204" pitchFamily="18" charset="0"/>
+                          </a:rPr>
+                        </m:ctrlPr>
+                      </m:sSubPr>
+                      <m:e>
+                        <m:r>
+                          <a:rPr lang="en-US" b="0" i="1" smtClean="0">
+                            <a:latin typeface="Cambria Math" panose="02040503050406030204" pitchFamily="18" charset="0"/>
+                          </a:rPr>
+                          <m:t>𝑦</m:t>
+                        </m:r>
+                      </m:e>
+                      <m:sub>
+                        <m:r>
+                          <a:rPr lang="en-US" b="0" i="1" smtClean="0">
+                            <a:latin typeface="Cambria Math" panose="02040503050406030204" pitchFamily="18" charset="0"/>
+                          </a:rPr>
+                          <m:t>𝑚𝑎𝑟𝑔𝑖𝑛</m:t>
+                        </m:r>
+                      </m:sub>
+                    </m:sSub>
+                  </m:oMath>
+                </a14:m>
+                <a:endParaRPr lang="en-US" dirty="0"/>
+              </a:p>
+              <a:p>
+                <a:pPr marL="742950" lvl="1" indent="-285750">
+                  <a:buFont typeface="Arial" panose="020B0604020202020204" pitchFamily="34" charset="0"/>
+                  <a:buChar char="•"/>
+                </a:pPr>
+                <a:r>
+                  <a:rPr lang="en-US" dirty="0"/>
+                  <a:t>For QBER greater than </a:t>
+                </a:r>
+                <a14:m>
+                  <m:oMath xmlns:m="http://schemas.openxmlformats.org/officeDocument/2006/math">
+                    <m:r>
+                      <a:rPr lang="en-US" b="0" i="1" smtClean="0">
+                        <a:latin typeface="Cambria Math" panose="02040503050406030204" pitchFamily="18" charset="0"/>
+                      </a:rPr>
+                      <m:t>≈11%</m:t>
+                    </m:r>
+                  </m:oMath>
+                </a14:m>
+                <a:r>
+                  <a:rPr lang="en-US" dirty="0"/>
+                  <a:t>, the information Eve has </a:t>
+                </a:r>
+                <a:r>
+                  <a:rPr lang="en-US"/>
+                  <a:t>prohibits compression </a:t>
+                </a:r>
+                <a:r>
+                  <a:rPr lang="en-US" dirty="0"/>
+                  <a:t>(i.e. </a:t>
+                </a:r>
+                <a14:m>
+                  <m:oMath xmlns:m="http://schemas.openxmlformats.org/officeDocument/2006/math">
+                    <m:r>
+                      <a:rPr lang="en-US" b="0" i="1" smtClean="0">
+                        <a:latin typeface="Cambria Math" panose="02040503050406030204" pitchFamily="18" charset="0"/>
+                      </a:rPr>
+                      <m:t>𝑚</m:t>
+                    </m:r>
+                    <m:r>
+                      <a:rPr lang="en-US" b="0" i="1" smtClean="0">
+                        <a:latin typeface="Cambria Math" panose="02040503050406030204" pitchFamily="18" charset="0"/>
+                      </a:rPr>
+                      <m:t>&lt;0</m:t>
+                    </m:r>
+                  </m:oMath>
+                </a14:m>
+                <a:r>
+                  <a:rPr lang="en-US" dirty="0"/>
+                  <a:t>)</a:t>
+                </a:r>
+              </a:p>
+              <a:p>
+                <a:pPr marL="285750" indent="-285750">
+                  <a:buFont typeface="Arial" panose="020B0604020202020204" pitchFamily="34" charset="0"/>
+                  <a:buChar char="•"/>
+                </a:pPr>
+                <a:r>
+                  <a:rPr lang="en-US" sz="2000" dirty="0">
+                    <a:solidFill>
+                      <a:srgbClr val="202123"/>
+                    </a:solidFill>
+                    <a:latin typeface="Calibri"/>
+                    <a:ea typeface="Calibri"/>
+                    <a:cs typeface="Calibri"/>
+                  </a:rPr>
+                  <a:t>By what method? Hashing</a:t>
+                </a:r>
+                <a:endParaRPr lang="en-US" dirty="0"/>
+              </a:p>
+              <a:p>
+                <a:pPr marL="742950" lvl="1" indent="-285750">
+                  <a:buFont typeface="Courier New" panose="020B0604020202020204" pitchFamily="34" charset="0"/>
+                  <a:buChar char="o"/>
+                </a:pPr>
+                <a:r>
+                  <a:rPr lang="en-US" sz="2000" dirty="0">
+                    <a:solidFill>
+                      <a:srgbClr val="202123"/>
+                    </a:solidFill>
+                    <a:latin typeface="Calibri"/>
+                    <a:ea typeface="Calibri"/>
+                    <a:cs typeface="Calibri"/>
+                  </a:rPr>
+                  <a:t>Hashing function is declared over public channel without providing any further information to Eve</a:t>
+                </a:r>
+              </a:p>
+              <a:p>
+                <a:pPr marL="742950" lvl="1" indent="-285750">
+                  <a:buFont typeface="Courier New" panose="020B0604020202020204" pitchFamily="34" charset="0"/>
+                  <a:buChar char="o"/>
+                </a:pPr>
+                <a:r>
+                  <a:rPr lang="en-US" sz="2000" dirty="0">
+                    <a:solidFill>
+                      <a:srgbClr val="202123"/>
+                    </a:solidFill>
+                    <a:latin typeface="Calibri"/>
+                    <a:ea typeface="Calibri"/>
+                    <a:cs typeface="Calibri"/>
+                  </a:rPr>
+                  <a:t>Toeplitz matrix</a:t>
+                </a:r>
+              </a:p>
+              <a:p>
+                <a:pPr marL="285750" indent="-285750">
+                  <a:buFont typeface="Arial" panose="020B0604020202020204" pitchFamily="34" charset="0"/>
+                  <a:buChar char="•"/>
+                </a:pPr>
+                <a:r>
+                  <a:rPr lang="en-US" sz="2000" dirty="0">
+                    <a:solidFill>
+                      <a:srgbClr val="202123"/>
+                    </a:solidFill>
+                    <a:latin typeface="Calibri" panose="020F0502020204030204" pitchFamily="34" charset="0"/>
+                    <a:cs typeface="Calibri" panose="020F0502020204030204" pitchFamily="34" charset="0"/>
+                  </a:rPr>
+                  <a:t>Results:</a:t>
+                </a:r>
+              </a:p>
+              <a:p>
+                <a:pPr marL="742950" lvl="1" indent="-285750">
+                  <a:buFont typeface="Courier New" panose="02070309020205020404" pitchFamily="49" charset="0"/>
+                  <a:buChar char="o"/>
+                </a:pPr>
+                <a:r>
+                  <a:rPr lang="en-US" dirty="0">
+                    <a:solidFill>
+                      <a:srgbClr val="202123"/>
+                    </a:solidFill>
+                    <a:latin typeface="Calibri"/>
+                    <a:ea typeface="Calibri"/>
+                    <a:cs typeface="Calibri"/>
+                  </a:rPr>
+                  <a:t>Instead of a 64-bit key where Eve has 5 sets of parity checks, we have 39 bits of private information</a:t>
+                </a:r>
+              </a:p>
+              <a:p>
+                <a:pPr marL="742950" lvl="1" indent="-285750">
+                  <a:buFont typeface="Courier New" panose="02070309020205020404" pitchFamily="49" charset="0"/>
+                  <a:buChar char="o"/>
+                </a:pPr>
+                <a:r>
+                  <a:rPr lang="en-US" dirty="0">
+                    <a:solidFill>
+                      <a:srgbClr val="202123"/>
+                    </a:solidFill>
+                    <a:latin typeface="Calibri"/>
+                    <a:ea typeface="Calibri"/>
+                    <a:cs typeface="Calibri"/>
+                  </a:rPr>
+                  <a:t>A shorter but more secure key</a:t>
+                </a:r>
+                <a:endParaRPr lang="en-US" dirty="0">
+                  <a:solidFill>
+                    <a:srgbClr val="202123"/>
+                  </a:solidFill>
+                  <a:latin typeface="Calibri" panose="020F0502020204030204" pitchFamily="34" charset="0"/>
+                  <a:ea typeface="Calibri"/>
+                  <a:cs typeface="Calibri" panose="020F0502020204030204" pitchFamily="34" charset="0"/>
+                </a:endParaRPr>
+              </a:p>
+              <a:p>
+                <a:pPr marL="742950" lvl="1" indent="-285750">
+                  <a:buFont typeface="Courier New" panose="02070309020205020404" pitchFamily="49" charset="0"/>
+                  <a:buChar char="o"/>
+                </a:pPr>
+                <a:r>
+                  <a:rPr lang="en-US" dirty="0">
+                    <a:solidFill>
+                      <a:srgbClr val="202123"/>
+                    </a:solidFill>
+                    <a:latin typeface="Calibri"/>
+                    <a:ea typeface="Calibri"/>
+                    <a:cs typeface="Calibri"/>
+                  </a:rPr>
+                  <a:t>Example:</a:t>
+                </a:r>
+                <a:endParaRPr lang="en-US" dirty="0">
+                  <a:solidFill>
+                    <a:srgbClr val="202123"/>
+                  </a:solidFill>
+                  <a:latin typeface="Calibri" panose="020F0502020204030204" pitchFamily="34" charset="0"/>
+                  <a:ea typeface="Calibri"/>
+                  <a:cs typeface="Calibri" panose="020F0502020204030204" pitchFamily="34" charset="0"/>
+                </a:endParaRPr>
+              </a:p>
+              <a:p>
+                <a:pPr marL="1200150" lvl="2" indent="-285750">
+                  <a:buFont typeface="Wingdings" panose="02070309020205020404" pitchFamily="49" charset="0"/>
+                  <a:buChar char="§"/>
+                </a:pPr>
+                <a:r>
+                  <a:rPr lang="en-US" dirty="0">
+                    <a:solidFill>
+                      <a:srgbClr val="202123"/>
+                    </a:solidFill>
+                    <a:ea typeface="+mn-lt"/>
+                    <a:cs typeface="+mn-lt"/>
+                  </a:rPr>
+                  <a:t>To encode "BB84"</a:t>
+                </a:r>
+              </a:p>
+              <a:p>
+                <a:pPr lvl="2"/>
+                <a:r>
+                  <a:rPr lang="en-US" dirty="0">
+                    <a:solidFill>
+                      <a:srgbClr val="202123"/>
+                    </a:solidFill>
+                    <a:ea typeface="+mn-lt"/>
+                    <a:cs typeface="+mn-lt"/>
+                  </a:rPr>
+                  <a:t>Key:  11110111001101011111011010111100</a:t>
+                </a:r>
+              </a:p>
+              <a:p>
+                <a:pPr lvl="2"/>
+                <a:r>
+                  <a:rPr lang="en-US" dirty="0"/>
+                  <a:t>Cipher Text: 11001111101011000101001111011001</a:t>
+                </a:r>
+              </a:p>
+              <a:p>
+                <a:pPr lvl="2"/>
+                <a:r>
+                  <a:rPr lang="en-US" dirty="0">
+                    <a:ea typeface="Calibri" panose="020F0502020204030204"/>
+                    <a:cs typeface="Calibri" panose="020F0502020204030204"/>
+                  </a:rPr>
+                  <a:t>Decoded: </a:t>
+                </a:r>
+                <a:r>
+                  <a:rPr lang="en-US" dirty="0">
+                    <a:ea typeface="+mn-lt"/>
+                    <a:cs typeface="+mn-lt"/>
+                  </a:rPr>
+                  <a:t>00000000010000100000100000000010</a:t>
+                </a:r>
+                <a:endParaRPr lang="en-US" dirty="0"/>
+              </a:p>
+            </p:txBody>
+          </p:sp>
+        </mc:Choice>
+        <mc:Fallback>
+          <p:sp>
+            <p:nvSpPr>
+              <p:cNvPr id="9" name="TextBox 8">
+                <a:extLst>
+                  <a:ext uri="{FF2B5EF4-FFF2-40B4-BE49-F238E27FC236}">
+                    <a16:creationId xmlns:a16="http://schemas.microsoft.com/office/drawing/2014/main" id="{F5F91DD6-6252-5987-ED81-0F61A3E07FAE}"/>
+                  </a:ext>
+                </a:extLst>
+              </p:cNvPr>
+              <p:cNvSpPr txBox="1">
+                <a:spLocks noRot="1" noChangeAspect="1" noMove="1" noResize="1" noEditPoints="1" noAdjustHandles="1" noChangeArrowheads="1" noChangeShapeType="1" noTextEdit="1"/>
+              </p:cNvSpPr>
+              <p:nvPr/>
+            </p:nvSpPr>
+            <p:spPr>
+              <a:xfrm>
+                <a:off x="457200" y="1181100"/>
+                <a:ext cx="10590028" cy="4731552"/>
+              </a:xfrm>
+              <a:prstGeom prst="rect">
+                <a:avLst/>
+              </a:prstGeom>
+              <a:blipFill>
+                <a:blip r:embed="rId2"/>
+                <a:stretch>
+                  <a:fillRect l="-518" t="-773" r="-979" b="-1160"/>
+                </a:stretch>
+              </a:blipFill>
+            </p:spPr>
+            <p:txBody>
+              <a:bodyPr/>
+              <a:lstStyle/>
+              <a:p>
+                <a:r>
+                  <a:rPr lang="en-US">
+                    <a:noFill/>
+                  </a:rPr>
+                  <a:t> </a:t>
+                </a:r>
+              </a:p>
+            </p:txBody>
+          </p:sp>
+        </mc:Fallback>
+      </mc:AlternateContent>
     </p:spTree>
     <p:extLst>
       <p:ext uri="{BB962C8B-B14F-4D97-AF65-F5344CB8AC3E}">
@@ -5208,7 +5601,7 @@
               <a:buChar char="•"/>
             </a:pPr>
             <a:r>
-              <a:rPr lang="en-US" sz="2000">
+              <a:rPr lang="en-US" sz="2000" dirty="0">
                 <a:solidFill>
                   <a:srgbClr val="202123"/>
                 </a:solidFill>
@@ -5227,7 +5620,7 @@
               <a:buChar char="•"/>
             </a:pPr>
             <a:r>
-              <a:rPr lang="en-US" sz="2000">
+              <a:rPr lang="en-US" sz="2000" dirty="0">
                 <a:solidFill>
                   <a:srgbClr val="202123"/>
                 </a:solidFill>
@@ -5245,7 +5638,7 @@
               <a:buFont typeface="Arial" panose="020B0604020202020204" pitchFamily="34" charset="0"/>
               <a:buChar char="•"/>
             </a:pPr>
-            <a:endParaRPr lang="en-US" sz="2000">
+            <a:endParaRPr lang="en-US" sz="2000" dirty="0">
               <a:solidFill>
                 <a:srgbClr val="202123"/>
               </a:solidFill>

</xml_diff>

<commit_message>
Adding content to final three slides of PPT
</commit_message>
<xml_diff>
--- a/615_781_Kuta_Nguyen_McLain.pptx
+++ b/615_781_Kuta_Nguyen_McLain.pptx
@@ -117,6 +117,11 @@
       </a:defRPr>
     </a:lvl9pPr>
   </p:defaultTextStyle>
+  <p:extLst>
+    <p:ext uri="{EFAFB233-063F-42B5-8137-9DF3F51BA10A}">
+      <p15:sldGuideLst xmlns:p15="http://schemas.microsoft.com/office/powerpoint/2012/main"/>
+    </p:ext>
+  </p:extLst>
 </p:presentation>
 </file>
 
@@ -195,83 +200,6 @@
             <ac:spMk id="7" creationId="{E4378A81-279B-CA9A-8E50-130D2D276DA6}"/>
           </ac:spMkLst>
         </pc:spChg>
-      </pc:sldChg>
-    </pc:docChg>
-  </pc:docChgLst>
-  <pc:docChgLst>
-    <pc:chgData name="Uyen P. Nguyen" userId="S::unguyen7@jh.edu::92021b55-417f-458a-90a7-cf14ced67da3" providerId="AD" clId="Web-{1C5DA43F-1144-560B-A996-9F9957834AF2}"/>
-    <pc:docChg chg="modSld">
-      <pc:chgData name="Uyen P. Nguyen" userId="S::unguyen7@jh.edu::92021b55-417f-458a-90a7-cf14ced67da3" providerId="AD" clId="Web-{1C5DA43F-1144-560B-A996-9F9957834AF2}" dt="2026-05-03T01:28:46.789" v="180" actId="20577"/>
-      <pc:docMkLst>
-        <pc:docMk/>
-      </pc:docMkLst>
-      <pc:sldChg chg="modSp">
-        <pc:chgData name="Uyen P. Nguyen" userId="S::unguyen7@jh.edu::92021b55-417f-458a-90a7-cf14ced67da3" providerId="AD" clId="Web-{1C5DA43F-1144-560B-A996-9F9957834AF2}" dt="2026-05-03T01:28:46.789" v="180" actId="20577"/>
-        <pc:sldMkLst>
-          <pc:docMk/>
-          <pc:sldMk cId="2133178391" sldId="257"/>
-        </pc:sldMkLst>
-        <pc:spChg chg="mod">
-          <ac:chgData name="Uyen P. Nguyen" userId="S::unguyen7@jh.edu::92021b55-417f-458a-90a7-cf14ced67da3" providerId="AD" clId="Web-{1C5DA43F-1144-560B-A996-9F9957834AF2}" dt="2026-05-03T00:49:04.439" v="76" actId="20577"/>
-          <ac:spMkLst>
-            <pc:docMk/>
-            <pc:sldMk cId="2133178391" sldId="257"/>
-            <ac:spMk id="7" creationId="{D159B653-A360-6E33-D2F6-A0D58B9935A5}"/>
-          </ac:spMkLst>
-        </pc:spChg>
-        <pc:spChg chg="mod">
-          <ac:chgData name="Uyen P. Nguyen" userId="S::unguyen7@jh.edu::92021b55-417f-458a-90a7-cf14ced67da3" providerId="AD" clId="Web-{1C5DA43F-1144-560B-A996-9F9957834AF2}" dt="2026-05-03T01:28:46.789" v="180" actId="20577"/>
-          <ac:spMkLst>
-            <pc:docMk/>
-            <pc:sldMk cId="2133178391" sldId="257"/>
-            <ac:spMk id="9" creationId="{EABC739E-24F8-66FD-A37D-4CF4952DF00F}"/>
-          </ac:spMkLst>
-        </pc:spChg>
-      </pc:sldChg>
-      <pc:sldChg chg="modSp">
-        <pc:chgData name="Uyen P. Nguyen" userId="S::unguyen7@jh.edu::92021b55-417f-458a-90a7-cf14ced67da3" providerId="AD" clId="Web-{1C5DA43F-1144-560B-A996-9F9957834AF2}" dt="2026-05-03T00:49:00.532" v="72" actId="20577"/>
-        <pc:sldMkLst>
-          <pc:docMk/>
-          <pc:sldMk cId="1284274485" sldId="259"/>
-        </pc:sldMkLst>
-        <pc:spChg chg="mod">
-          <ac:chgData name="Uyen P. Nguyen" userId="S::unguyen7@jh.edu::92021b55-417f-458a-90a7-cf14ced67da3" providerId="AD" clId="Web-{1C5DA43F-1144-560B-A996-9F9957834AF2}" dt="2026-05-03T00:49:00.532" v="72" actId="20577"/>
-          <ac:spMkLst>
-            <pc:docMk/>
-            <pc:sldMk cId="1284274485" sldId="259"/>
-            <ac:spMk id="7" creationId="{32741F24-76C7-9C01-1DBD-5EE3762FAACA}"/>
-          </ac:spMkLst>
-        </pc:spChg>
-      </pc:sldChg>
-      <pc:sldChg chg="modSp">
-        <pc:chgData name="Uyen P. Nguyen" userId="S::unguyen7@jh.edu::92021b55-417f-458a-90a7-cf14ced67da3" providerId="AD" clId="Web-{1C5DA43F-1144-560B-A996-9F9957834AF2}" dt="2026-05-03T00:48:55.797" v="67" actId="20577"/>
-        <pc:sldMkLst>
-          <pc:docMk/>
-          <pc:sldMk cId="1027488440" sldId="260"/>
-        </pc:sldMkLst>
-        <pc:spChg chg="mod">
-          <ac:chgData name="Uyen P. Nguyen" userId="S::unguyen7@jh.edu::92021b55-417f-458a-90a7-cf14ced67da3" providerId="AD" clId="Web-{1C5DA43F-1144-560B-A996-9F9957834AF2}" dt="2026-05-03T00:48:55.797" v="67" actId="20577"/>
-          <ac:spMkLst>
-            <pc:docMk/>
-            <pc:sldMk cId="1027488440" sldId="260"/>
-            <ac:spMk id="7" creationId="{2C42AF74-C537-A886-53B7-E8DF3240B7B7}"/>
-          </ac:spMkLst>
-        </pc:spChg>
-      </pc:sldChg>
-      <pc:sldChg chg="modSp">
-        <pc:chgData name="Uyen P. Nguyen" userId="S::unguyen7@jh.edu::92021b55-417f-458a-90a7-cf14ced67da3" providerId="AD" clId="Web-{1C5DA43F-1144-560B-A996-9F9957834AF2}" dt="2026-05-03T00:46:37.606" v="25"/>
-        <pc:sldMkLst>
-          <pc:docMk/>
-          <pc:sldMk cId="2092433718" sldId="265"/>
-        </pc:sldMkLst>
-        <pc:graphicFrameChg chg="mod modGraphic">
-          <ac:chgData name="Uyen P. Nguyen" userId="S::unguyen7@jh.edu::92021b55-417f-458a-90a7-cf14ced67da3" providerId="AD" clId="Web-{1C5DA43F-1144-560B-A996-9F9957834AF2}" dt="2026-05-03T00:46:37.606" v="25"/>
-          <ac:graphicFrameMkLst>
-            <pc:docMk/>
-            <pc:sldMk cId="2092433718" sldId="265"/>
-            <ac:graphicFrameMk id="3" creationId="{15498308-56C6-0976-7133-85BE4FA98101}"/>
-          </ac:graphicFrameMkLst>
-        </pc:graphicFrameChg>
       </pc:sldChg>
     </pc:docChg>
   </pc:docChgLst>
@@ -459,6 +387,83 @@
             <ac:picMk id="8" creationId="{B38A110A-4554-DD53-7B39-D305EC31083C}"/>
           </ac:picMkLst>
         </pc:picChg>
+      </pc:sldChg>
+    </pc:docChg>
+  </pc:docChgLst>
+  <pc:docChgLst>
+    <pc:chgData name="Uyen P. Nguyen" userId="S::unguyen7@jh.edu::92021b55-417f-458a-90a7-cf14ced67da3" providerId="AD" clId="Web-{1C5DA43F-1144-560B-A996-9F9957834AF2}"/>
+    <pc:docChg chg="modSld">
+      <pc:chgData name="Uyen P. Nguyen" userId="S::unguyen7@jh.edu::92021b55-417f-458a-90a7-cf14ced67da3" providerId="AD" clId="Web-{1C5DA43F-1144-560B-A996-9F9957834AF2}" dt="2026-05-03T01:28:46.789" v="180" actId="20577"/>
+      <pc:docMkLst>
+        <pc:docMk/>
+      </pc:docMkLst>
+      <pc:sldChg chg="modSp">
+        <pc:chgData name="Uyen P. Nguyen" userId="S::unguyen7@jh.edu::92021b55-417f-458a-90a7-cf14ced67da3" providerId="AD" clId="Web-{1C5DA43F-1144-560B-A996-9F9957834AF2}" dt="2026-05-03T01:28:46.789" v="180" actId="20577"/>
+        <pc:sldMkLst>
+          <pc:docMk/>
+          <pc:sldMk cId="2133178391" sldId="257"/>
+        </pc:sldMkLst>
+        <pc:spChg chg="mod">
+          <ac:chgData name="Uyen P. Nguyen" userId="S::unguyen7@jh.edu::92021b55-417f-458a-90a7-cf14ced67da3" providerId="AD" clId="Web-{1C5DA43F-1144-560B-A996-9F9957834AF2}" dt="2026-05-03T00:49:04.439" v="76" actId="20577"/>
+          <ac:spMkLst>
+            <pc:docMk/>
+            <pc:sldMk cId="2133178391" sldId="257"/>
+            <ac:spMk id="7" creationId="{D159B653-A360-6E33-D2F6-A0D58B9935A5}"/>
+          </ac:spMkLst>
+        </pc:spChg>
+        <pc:spChg chg="mod">
+          <ac:chgData name="Uyen P. Nguyen" userId="S::unguyen7@jh.edu::92021b55-417f-458a-90a7-cf14ced67da3" providerId="AD" clId="Web-{1C5DA43F-1144-560B-A996-9F9957834AF2}" dt="2026-05-03T01:28:46.789" v="180" actId="20577"/>
+          <ac:spMkLst>
+            <pc:docMk/>
+            <pc:sldMk cId="2133178391" sldId="257"/>
+            <ac:spMk id="9" creationId="{EABC739E-24F8-66FD-A37D-4CF4952DF00F}"/>
+          </ac:spMkLst>
+        </pc:spChg>
+      </pc:sldChg>
+      <pc:sldChg chg="modSp">
+        <pc:chgData name="Uyen P. Nguyen" userId="S::unguyen7@jh.edu::92021b55-417f-458a-90a7-cf14ced67da3" providerId="AD" clId="Web-{1C5DA43F-1144-560B-A996-9F9957834AF2}" dt="2026-05-03T00:49:00.532" v="72" actId="20577"/>
+        <pc:sldMkLst>
+          <pc:docMk/>
+          <pc:sldMk cId="1284274485" sldId="259"/>
+        </pc:sldMkLst>
+        <pc:spChg chg="mod">
+          <ac:chgData name="Uyen P. Nguyen" userId="S::unguyen7@jh.edu::92021b55-417f-458a-90a7-cf14ced67da3" providerId="AD" clId="Web-{1C5DA43F-1144-560B-A996-9F9957834AF2}" dt="2026-05-03T00:49:00.532" v="72" actId="20577"/>
+          <ac:spMkLst>
+            <pc:docMk/>
+            <pc:sldMk cId="1284274485" sldId="259"/>
+            <ac:spMk id="7" creationId="{32741F24-76C7-9C01-1DBD-5EE3762FAACA}"/>
+          </ac:spMkLst>
+        </pc:spChg>
+      </pc:sldChg>
+      <pc:sldChg chg="modSp">
+        <pc:chgData name="Uyen P. Nguyen" userId="S::unguyen7@jh.edu::92021b55-417f-458a-90a7-cf14ced67da3" providerId="AD" clId="Web-{1C5DA43F-1144-560B-A996-9F9957834AF2}" dt="2026-05-03T00:48:55.797" v="67" actId="20577"/>
+        <pc:sldMkLst>
+          <pc:docMk/>
+          <pc:sldMk cId="1027488440" sldId="260"/>
+        </pc:sldMkLst>
+        <pc:spChg chg="mod">
+          <ac:chgData name="Uyen P. Nguyen" userId="S::unguyen7@jh.edu::92021b55-417f-458a-90a7-cf14ced67da3" providerId="AD" clId="Web-{1C5DA43F-1144-560B-A996-9F9957834AF2}" dt="2026-05-03T00:48:55.797" v="67" actId="20577"/>
+          <ac:spMkLst>
+            <pc:docMk/>
+            <pc:sldMk cId="1027488440" sldId="260"/>
+            <ac:spMk id="7" creationId="{2C42AF74-C537-A886-53B7-E8DF3240B7B7}"/>
+          </ac:spMkLst>
+        </pc:spChg>
+      </pc:sldChg>
+      <pc:sldChg chg="modSp">
+        <pc:chgData name="Uyen P. Nguyen" userId="S::unguyen7@jh.edu::92021b55-417f-458a-90a7-cf14ced67da3" providerId="AD" clId="Web-{1C5DA43F-1144-560B-A996-9F9957834AF2}" dt="2026-05-03T00:46:37.606" v="25"/>
+        <pc:sldMkLst>
+          <pc:docMk/>
+          <pc:sldMk cId="2092433718" sldId="265"/>
+        </pc:sldMkLst>
+        <pc:graphicFrameChg chg="mod modGraphic">
+          <ac:chgData name="Uyen P. Nguyen" userId="S::unguyen7@jh.edu::92021b55-417f-458a-90a7-cf14ced67da3" providerId="AD" clId="Web-{1C5DA43F-1144-560B-A996-9F9957834AF2}" dt="2026-05-03T00:46:37.606" v="25"/>
+          <ac:graphicFrameMkLst>
+            <pc:docMk/>
+            <pc:sldMk cId="2092433718" sldId="265"/>
+            <ac:graphicFrameMk id="3" creationId="{15498308-56C6-0976-7133-85BE4FA98101}"/>
+          </ac:graphicFrameMkLst>
+        </pc:graphicFrameChg>
       </pc:sldChg>
     </pc:docChg>
   </pc:docChgLst>
@@ -4471,8 +4476,8 @@
           </a:p>
         </p:txBody>
       </p:sp>
-      <mc:AlternateContent xmlns:mc="http://schemas.openxmlformats.org/markup-compatibility/2006">
-        <mc:Choice xmlns:a14="http://schemas.microsoft.com/office/drawing/2010/main" Requires="a14">
+      <mc:AlternateContent xmlns:mc="http://schemas.openxmlformats.org/markup-compatibility/2006" xmlns:a14="http://schemas.microsoft.com/office/drawing/2010/main">
+        <mc:Choice Requires="a14">
           <p:sp>
             <p:nvSpPr>
               <p:cNvPr id="9" name="TextBox 8">
@@ -4819,7 +4824,7 @@
             </p:txBody>
           </p:sp>
         </mc:Choice>
-        <mc:Fallback>
+        <mc:Fallback xmlns="">
           <p:sp>
             <p:nvSpPr>
               <p:cNvPr id="9" name="TextBox 8">
@@ -4984,8 +4989,8 @@
           </a:p>
         </p:txBody>
       </p:sp>
-      <mc:AlternateContent xmlns:mc="http://schemas.openxmlformats.org/markup-compatibility/2006">
-        <mc:Choice xmlns:a14="http://schemas.microsoft.com/office/drawing/2010/main" Requires="a14">
+      <mc:AlternateContent xmlns:mc="http://schemas.openxmlformats.org/markup-compatibility/2006" xmlns:a14="http://schemas.microsoft.com/office/drawing/2010/main">
+        <mc:Choice Requires="a14">
           <p:sp>
             <p:nvSpPr>
               <p:cNvPr id="9" name="TextBox 8">
@@ -5180,15 +5185,7 @@
                 </a14:m>
                 <a:r>
                   <a:rPr lang="en-US" dirty="0"/>
-                  <a:t>, the information Eve has </a:t>
-                </a:r>
-                <a:r>
-                  <a:rPr lang="en-US"/>
-                  <a:t>prohibits compression </a:t>
-                </a:r>
-                <a:r>
-                  <a:rPr lang="en-US" dirty="0"/>
-                  <a:t>(i.e. </a:t>
+                  <a:t>, the information Eve has prohibits compression (i.e. </a:t>
                 </a:r>
                 <a14:m>
                   <m:oMath xmlns:m="http://schemas.openxmlformats.org/officeDocument/2006/math">
@@ -5403,7 +5400,7 @@
             </p:txBody>
           </p:sp>
         </mc:Choice>
-        <mc:Fallback>
+        <mc:Fallback xmlns="">
           <p:sp>
             <p:nvSpPr>
               <p:cNvPr id="9" name="TextBox 8">
@@ -5568,87 +5565,310 @@
           </a:p>
         </p:txBody>
       </p:sp>
-      <p:sp>
-        <p:nvSpPr>
-          <p:cNvPr id="9" name="TextBox 8">
-            <a:extLst>
-              <a:ext uri="{FF2B5EF4-FFF2-40B4-BE49-F238E27FC236}">
-                <a16:creationId xmlns:a16="http://schemas.microsoft.com/office/drawing/2014/main" id="{79ED7CEE-C5E9-CD5A-272A-71445B3DFEC7}"/>
-              </a:ext>
-            </a:extLst>
-          </p:cNvPr>
-          <p:cNvSpPr txBox="1"/>
-          <p:nvPr/>
-        </p:nvSpPr>
-        <p:spPr>
-          <a:xfrm>
-            <a:off x="457200" y="1181100"/>
-            <a:ext cx="10590028" cy="1169551"/>
-          </a:xfrm>
-          <a:prstGeom prst="rect">
-            <a:avLst/>
-          </a:prstGeom>
-          <a:noFill/>
-        </p:spPr>
-        <p:txBody>
-          <a:bodyPr wrap="square" lIns="91440" tIns="45720" rIns="91440" bIns="45720" anchor="t">
-            <a:spAutoFit/>
-          </a:bodyPr>
-          <a:lstStyle/>
-          <a:p>
-            <a:pPr marL="285750" indent="-285750">
-              <a:buFont typeface="Arial" panose="020B0604020202020204" pitchFamily="34" charset="0"/>
-              <a:buChar char="•"/>
-            </a:pPr>
-            <a:r>
-              <a:rPr lang="en-US" sz="2000" dirty="0">
-                <a:solidFill>
-                  <a:srgbClr val="202123"/>
-                </a:solidFill>
-                <a:latin typeface="Calibri" panose="020F0502020204030204" pitchFamily="34" charset="0"/>
-                <a:cs typeface="Calibri" panose="020F0502020204030204" pitchFamily="34" charset="0"/>
-              </a:rPr>
-              <a:t>[…]</a:t>
-            </a:r>
-          </a:p>
-          <a:p>
-            <a:pPr marL="285750" indent="-285750">
-              <a:spcBef>
-                <a:spcPts val="600"/>
-              </a:spcBef>
-              <a:buFont typeface="Arial" panose="020B0604020202020204" pitchFamily="34" charset="0"/>
-              <a:buChar char="•"/>
-            </a:pPr>
-            <a:r>
-              <a:rPr lang="en-US" sz="2000" dirty="0">
-                <a:solidFill>
-                  <a:srgbClr val="202123"/>
-                </a:solidFill>
-                <a:latin typeface="Calibri" panose="020F0502020204030204" pitchFamily="34" charset="0"/>
-                <a:cs typeface="Calibri" panose="020F0502020204030204" pitchFamily="34" charset="0"/>
-              </a:rPr>
-              <a:t>Limitation</a:t>
-            </a:r>
-          </a:p>
-          <a:p>
-            <a:pPr marL="285750" indent="-285750">
-              <a:spcBef>
-                <a:spcPts val="600"/>
-              </a:spcBef>
-              <a:buFont typeface="Arial" panose="020B0604020202020204" pitchFamily="34" charset="0"/>
-              <a:buChar char="•"/>
-            </a:pPr>
-            <a:endParaRPr lang="en-US" sz="2000" dirty="0">
-              <a:solidFill>
-                <a:srgbClr val="202123"/>
-              </a:solidFill>
-              <a:latin typeface="Calibri" panose="020F0502020204030204" pitchFamily="34" charset="0"/>
-              <a:ea typeface="Calibri"/>
-              <a:cs typeface="Calibri" panose="020F0502020204030204" pitchFamily="34" charset="0"/>
-            </a:endParaRPr>
-          </a:p>
-        </p:txBody>
-      </p:sp>
+      <mc:AlternateContent xmlns:mc="http://schemas.openxmlformats.org/markup-compatibility/2006">
+        <mc:Choice xmlns:a14="http://schemas.microsoft.com/office/drawing/2010/main" Requires="a14">
+          <p:sp>
+            <p:nvSpPr>
+              <p:cNvPr id="9" name="TextBox 8">
+                <a:extLst>
+                  <a:ext uri="{FF2B5EF4-FFF2-40B4-BE49-F238E27FC236}">
+                    <a16:creationId xmlns:a16="http://schemas.microsoft.com/office/drawing/2014/main" id="{79ED7CEE-C5E9-CD5A-272A-71445B3DFEC7}"/>
+                  </a:ext>
+                </a:extLst>
+              </p:cNvPr>
+              <p:cNvSpPr txBox="1"/>
+              <p:nvPr/>
+            </p:nvSpPr>
+            <p:spPr>
+              <a:xfrm>
+                <a:off x="457200" y="1181100"/>
+                <a:ext cx="10590028" cy="3785652"/>
+              </a:xfrm>
+              <a:prstGeom prst="rect">
+                <a:avLst/>
+              </a:prstGeom>
+              <a:noFill/>
+            </p:spPr>
+            <p:txBody>
+              <a:bodyPr wrap="square" lIns="91440" tIns="45720" rIns="91440" bIns="45720" anchor="t">
+                <a:spAutoFit/>
+              </a:bodyPr>
+              <a:lstStyle/>
+              <a:p>
+                <a:pPr marL="285750" indent="-285750">
+                  <a:buFont typeface="Arial" panose="020B0604020202020204" pitchFamily="34" charset="0"/>
+                  <a:buChar char="•"/>
+                </a:pPr>
+                <a:r>
+                  <a:rPr lang="en-US" sz="2000" dirty="0">
+                    <a:solidFill>
+                      <a:srgbClr val="202123"/>
+                    </a:solidFill>
+                    <a:latin typeface="Calibri" panose="020F0502020204030204" pitchFamily="34" charset="0"/>
+                    <a:cs typeface="Calibri" panose="020F0502020204030204" pitchFamily="34" charset="0"/>
+                  </a:rPr>
+                  <a:t>BB84 is provably secure QKD protocol against eavesdropping</a:t>
+                </a:r>
+              </a:p>
+              <a:p>
+                <a:pPr marL="285750" indent="-285750">
+                  <a:spcBef>
+                    <a:spcPts val="600"/>
+                  </a:spcBef>
+                  <a:buFont typeface="Arial" panose="020B0604020202020204" pitchFamily="34" charset="0"/>
+                  <a:buChar char="•"/>
+                </a:pPr>
+                <a:r>
+                  <a:rPr lang="en-US" sz="2000" dirty="0">
+                    <a:solidFill>
+                      <a:srgbClr val="202123"/>
+                    </a:solidFill>
+                    <a:latin typeface="Calibri" panose="020F0502020204030204" pitchFamily="34" charset="0"/>
+                    <a:cs typeface="Calibri" panose="020F0502020204030204" pitchFamily="34" charset="0"/>
+                  </a:rPr>
+                  <a:t>Noticeable limitations:</a:t>
+                </a:r>
+              </a:p>
+              <a:p>
+                <a:pPr marL="742950" lvl="1" indent="-285750">
+                  <a:spcBef>
+                    <a:spcPts val="600"/>
+                  </a:spcBef>
+                  <a:buFont typeface="Arial" panose="020B0604020202020204" pitchFamily="34" charset="0"/>
+                  <a:buChar char="•"/>
+                </a:pPr>
+                <a:r>
+                  <a:rPr lang="en-US" sz="2000" dirty="0">
+                    <a:solidFill>
+                      <a:srgbClr val="202123"/>
+                    </a:solidFill>
+                    <a:latin typeface="Calibri" panose="020F0502020204030204" pitchFamily="34" charset="0"/>
+                    <a:cs typeface="Calibri" panose="020F0502020204030204" pitchFamily="34" charset="0"/>
+                  </a:rPr>
+                  <a:t>Requires sufficiently low QBER to generate a secure key (</a:t>
+                </a:r>
+                <a14:m>
+                  <m:oMath xmlns:m="http://schemas.openxmlformats.org/officeDocument/2006/math">
+                    <m:r>
+                      <a:rPr lang="en-US" sz="2000" b="0" i="1" smtClean="0">
+                        <a:solidFill>
+                          <a:srgbClr val="202123"/>
+                        </a:solidFill>
+                        <a:latin typeface="Cambria Math" panose="02040503050406030204" pitchFamily="18" charset="0"/>
+                        <a:cs typeface="Calibri" panose="020F0502020204030204" pitchFamily="34" charset="0"/>
+                      </a:rPr>
+                      <m:t>𝑄𝐵𝐸𝑅</m:t>
+                    </m:r>
+                    <m:r>
+                      <a:rPr lang="en-US" sz="2000" b="0" i="1" smtClean="0">
+                        <a:solidFill>
+                          <a:srgbClr val="202123"/>
+                        </a:solidFill>
+                        <a:latin typeface="Cambria Math" panose="02040503050406030204" pitchFamily="18" charset="0"/>
+                        <a:cs typeface="Calibri" panose="020F0502020204030204" pitchFamily="34" charset="0"/>
+                      </a:rPr>
+                      <m:t>&lt;11%</m:t>
+                    </m:r>
+                  </m:oMath>
+                </a14:m>
+                <a:r>
+                  <a:rPr lang="en-US" sz="2000" dirty="0">
+                    <a:solidFill>
+                      <a:srgbClr val="202123"/>
+                    </a:solidFill>
+                    <a:latin typeface="Calibri" panose="020F0502020204030204" pitchFamily="34" charset="0"/>
+                    <a:cs typeface="Calibri" panose="020F0502020204030204" pitchFamily="34" charset="0"/>
+                  </a:rPr>
+                  <a:t>)</a:t>
+                </a:r>
+              </a:p>
+              <a:p>
+                <a:pPr marL="1200150" lvl="2" indent="-285750">
+                  <a:spcBef>
+                    <a:spcPts val="600"/>
+                  </a:spcBef>
+                  <a:buFont typeface="Arial" panose="020B0604020202020204" pitchFamily="34" charset="0"/>
+                  <a:buChar char="•"/>
+                </a:pPr>
+                <a:r>
+                  <a:rPr lang="en-US" sz="2000" dirty="0">
+                    <a:solidFill>
+                      <a:srgbClr val="202123"/>
+                    </a:solidFill>
+                    <a:latin typeface="Calibri" panose="020F0502020204030204" pitchFamily="34" charset="0"/>
+                    <a:cs typeface="Calibri" panose="020F0502020204030204" pitchFamily="34" charset="0"/>
+                  </a:rPr>
+                  <a:t>Difficult to implement in moderate-to-high noise-plus-interference environments </a:t>
+                </a:r>
+              </a:p>
+              <a:p>
+                <a:pPr marL="742950" lvl="1" indent="-285750">
+                  <a:spcBef>
+                    <a:spcPts val="600"/>
+                  </a:spcBef>
+                  <a:buFont typeface="Arial" panose="020B0604020202020204" pitchFamily="34" charset="0"/>
+                  <a:buChar char="•"/>
+                </a:pPr>
+                <a:r>
+                  <a:rPr lang="en-US" sz="2000" dirty="0">
+                    <a:solidFill>
+                      <a:srgbClr val="202123"/>
+                    </a:solidFill>
+                    <a:latin typeface="Calibri" panose="020F0502020204030204" pitchFamily="34" charset="0"/>
+                    <a:cs typeface="Calibri" panose="020F0502020204030204" pitchFamily="34" charset="0"/>
+                  </a:rPr>
+                  <a:t>Requires high information latency</a:t>
+                </a:r>
+              </a:p>
+              <a:p>
+                <a:pPr marL="1200150" lvl="2" indent="-285750">
+                  <a:spcBef>
+                    <a:spcPts val="600"/>
+                  </a:spcBef>
+                  <a:buFont typeface="Arial" panose="020B0604020202020204" pitchFamily="34" charset="0"/>
+                  <a:buChar char="•"/>
+                </a:pPr>
+                <a:r>
+                  <a:rPr lang="en-US" sz="2000" dirty="0">
+                    <a:solidFill>
+                      <a:srgbClr val="202123"/>
+                    </a:solidFill>
+                    <a:latin typeface="Calibri" panose="020F0502020204030204" pitchFamily="34" charset="0"/>
+                    <a:cs typeface="Calibri" panose="020F0502020204030204" pitchFamily="34" charset="0"/>
+                  </a:rPr>
+                  <a:t>Comparing basis selection and parities across the public channel is resource intensive</a:t>
+                </a:r>
+              </a:p>
+              <a:p>
+                <a:pPr marL="285750" indent="-285750">
+                  <a:spcBef>
+                    <a:spcPts val="600"/>
+                  </a:spcBef>
+                  <a:buFont typeface="Arial" panose="020B0604020202020204" pitchFamily="34" charset="0"/>
+                  <a:buChar char="•"/>
+                </a:pPr>
+                <a:r>
+                  <a:rPr lang="en-US" sz="2000" dirty="0">
+                    <a:solidFill>
+                      <a:srgbClr val="202123"/>
+                    </a:solidFill>
+                    <a:latin typeface="Calibri" panose="020F0502020204030204" pitchFamily="34" charset="0"/>
+                    <a:ea typeface="Calibri"/>
+                    <a:cs typeface="Calibri" panose="020F0502020204030204" pitchFamily="34" charset="0"/>
+                  </a:rPr>
+                  <a:t>Improvements:</a:t>
+                </a:r>
+              </a:p>
+              <a:p>
+                <a:pPr marL="742950" lvl="1" indent="-285750">
+                  <a:spcBef>
+                    <a:spcPts val="600"/>
+                  </a:spcBef>
+                  <a:buFont typeface="Arial" panose="020B0604020202020204" pitchFamily="34" charset="0"/>
+                  <a:buChar char="•"/>
+                </a:pPr>
+                <a:r>
+                  <a:rPr lang="en-US" sz="2000" dirty="0">
+                    <a:solidFill>
+                      <a:srgbClr val="202123"/>
+                    </a:solidFill>
+                    <a:latin typeface="Calibri" panose="020F0502020204030204" pitchFamily="34" charset="0"/>
+                    <a:ea typeface="Calibri"/>
+                    <a:cs typeface="Calibri" panose="020F0502020204030204" pitchFamily="34" charset="0"/>
+                  </a:rPr>
+                  <a:t>Cascade protocol can be replaced with a low-density parity check (LDPC) protocol to improve reconciliation efficiency</a:t>
+                </a:r>
+              </a:p>
+              <a:p>
+                <a:pPr marL="742950" lvl="1" indent="-285750">
+                  <a:spcBef>
+                    <a:spcPts val="600"/>
+                  </a:spcBef>
+                  <a:buFont typeface="Arial" panose="020B0604020202020204" pitchFamily="34" charset="0"/>
+                  <a:buChar char="•"/>
+                </a:pPr>
+                <a:r>
+                  <a:rPr lang="en-US" sz="2000" dirty="0">
+                    <a:solidFill>
+                      <a:srgbClr val="202123"/>
+                    </a:solidFill>
+                    <a:latin typeface="Calibri" panose="020F0502020204030204" pitchFamily="34" charset="0"/>
+                    <a:ea typeface="Calibri"/>
+                    <a:cs typeface="Calibri" panose="020F0502020204030204" pitchFamily="34" charset="0"/>
+                  </a:rPr>
+                  <a:t>Later QKD protocols such as </a:t>
+                </a:r>
+                <a:r>
+                  <a:rPr lang="en-US" sz="2000">
+                    <a:solidFill>
+                      <a:srgbClr val="202123"/>
+                    </a:solidFill>
+                    <a:latin typeface="Calibri" panose="020F0502020204030204" pitchFamily="34" charset="0"/>
+                    <a:ea typeface="Calibri"/>
+                    <a:cs typeface="Calibri" panose="020F0502020204030204" pitchFamily="34" charset="0"/>
+                  </a:rPr>
+                  <a:t>E91 uses </a:t>
+                </a:r>
+                <a:r>
+                  <a:rPr lang="en-US" sz="2000" dirty="0">
+                    <a:solidFill>
+                      <a:srgbClr val="202123"/>
+                    </a:solidFill>
+                    <a:latin typeface="Calibri" panose="020F0502020204030204" pitchFamily="34" charset="0"/>
+                    <a:ea typeface="Calibri"/>
+                    <a:cs typeface="Calibri" panose="020F0502020204030204" pitchFamily="34" charset="0"/>
+                  </a:rPr>
+                  <a:t>entanglement to provide device-independent security</a:t>
+                </a:r>
+              </a:p>
+            </p:txBody>
+          </p:sp>
+        </mc:Choice>
+        <mc:Fallback>
+          <p:sp>
+            <p:nvSpPr>
+              <p:cNvPr id="9" name="TextBox 8">
+                <a:extLst>
+                  <a:ext uri="{FF2B5EF4-FFF2-40B4-BE49-F238E27FC236}">
+                    <a16:creationId xmlns:a16="http://schemas.microsoft.com/office/drawing/2014/main" id="{79ED7CEE-C5E9-CD5A-272A-71445B3DFEC7}"/>
+                  </a:ext>
+                </a:extLst>
+              </p:cNvPr>
+              <p:cNvSpPr txBox="1">
+                <a:spLocks noRot="1" noChangeAspect="1" noMove="1" noResize="1" noEditPoints="1" noAdjustHandles="1" noChangeArrowheads="1" noChangeShapeType="1" noTextEdit="1"/>
+              </p:cNvSpPr>
+              <p:nvPr/>
+            </p:nvSpPr>
+            <p:spPr>
+              <a:xfrm>
+                <a:off x="457200" y="1181100"/>
+                <a:ext cx="10590028" cy="3785652"/>
+              </a:xfrm>
+              <a:prstGeom prst="rect">
+                <a:avLst/>
+              </a:prstGeom>
+              <a:blipFill>
+                <a:blip r:embed="rId2"/>
+                <a:stretch>
+                  <a:fillRect l="-518" t="-966" r="-230" b="-1932"/>
+                </a:stretch>
+              </a:blipFill>
+            </p:spPr>
+            <p:txBody>
+              <a:bodyPr/>
+              <a:lstStyle/>
+              <a:p>
+                <a:r>
+                  <a:rPr lang="en-US">
+                    <a:noFill/>
+                  </a:rPr>
+                  <a:t> </a:t>
+                </a:r>
+              </a:p>
+            </p:txBody>
+          </p:sp>
+        </mc:Fallback>
+      </mc:AlternateContent>
     </p:spTree>
     <p:extLst>
       <p:ext uri="{BB962C8B-B14F-4D97-AF65-F5344CB8AC3E}">

</xml_diff>

<commit_message>
Adding references to powerpoint
</commit_message>
<xml_diff>
--- a/615_781_Kuta_Nguyen_McLain.pptx
+++ b/615_781_Kuta_Nguyen_McLain.pptx
@@ -17,8 +17,9 @@
     <p:sldId id="262" r:id="rId11"/>
     <p:sldId id="263" r:id="rId12"/>
     <p:sldId id="264" r:id="rId13"/>
-    <p:sldId id="265" r:id="rId14"/>
-    <p:sldId id="266" r:id="rId15"/>
+    <p:sldId id="272" r:id="rId14"/>
+    <p:sldId id="265" r:id="rId15"/>
+    <p:sldId id="266" r:id="rId16"/>
   </p:sldIdLst>
   <p:sldSz cx="12192000" cy="6858000"/>
   <p:notesSz cx="6858000" cy="9144000"/>
@@ -200,6 +201,83 @@
             <ac:spMk id="7" creationId="{E4378A81-279B-CA9A-8E50-130D2D276DA6}"/>
           </ac:spMkLst>
         </pc:spChg>
+      </pc:sldChg>
+    </pc:docChg>
+  </pc:docChgLst>
+  <pc:docChgLst>
+    <pc:chgData name="Uyen P. Nguyen" userId="S::unguyen7@jh.edu::92021b55-417f-458a-90a7-cf14ced67da3" providerId="AD" clId="Web-{1C5DA43F-1144-560B-A996-9F9957834AF2}"/>
+    <pc:docChg chg="modSld">
+      <pc:chgData name="Uyen P. Nguyen" userId="S::unguyen7@jh.edu::92021b55-417f-458a-90a7-cf14ced67da3" providerId="AD" clId="Web-{1C5DA43F-1144-560B-A996-9F9957834AF2}" dt="2026-05-03T01:28:46.789" v="180" actId="20577"/>
+      <pc:docMkLst>
+        <pc:docMk/>
+      </pc:docMkLst>
+      <pc:sldChg chg="modSp">
+        <pc:chgData name="Uyen P. Nguyen" userId="S::unguyen7@jh.edu::92021b55-417f-458a-90a7-cf14ced67da3" providerId="AD" clId="Web-{1C5DA43F-1144-560B-A996-9F9957834AF2}" dt="2026-05-03T01:28:46.789" v="180" actId="20577"/>
+        <pc:sldMkLst>
+          <pc:docMk/>
+          <pc:sldMk cId="2133178391" sldId="257"/>
+        </pc:sldMkLst>
+        <pc:spChg chg="mod">
+          <ac:chgData name="Uyen P. Nguyen" userId="S::unguyen7@jh.edu::92021b55-417f-458a-90a7-cf14ced67da3" providerId="AD" clId="Web-{1C5DA43F-1144-560B-A996-9F9957834AF2}" dt="2026-05-03T00:49:04.439" v="76" actId="20577"/>
+          <ac:spMkLst>
+            <pc:docMk/>
+            <pc:sldMk cId="2133178391" sldId="257"/>
+            <ac:spMk id="7" creationId="{D159B653-A360-6E33-D2F6-A0D58B9935A5}"/>
+          </ac:spMkLst>
+        </pc:spChg>
+        <pc:spChg chg="mod">
+          <ac:chgData name="Uyen P. Nguyen" userId="S::unguyen7@jh.edu::92021b55-417f-458a-90a7-cf14ced67da3" providerId="AD" clId="Web-{1C5DA43F-1144-560B-A996-9F9957834AF2}" dt="2026-05-03T01:28:46.789" v="180" actId="20577"/>
+          <ac:spMkLst>
+            <pc:docMk/>
+            <pc:sldMk cId="2133178391" sldId="257"/>
+            <ac:spMk id="9" creationId="{EABC739E-24F8-66FD-A37D-4CF4952DF00F}"/>
+          </ac:spMkLst>
+        </pc:spChg>
+      </pc:sldChg>
+      <pc:sldChg chg="modSp">
+        <pc:chgData name="Uyen P. Nguyen" userId="S::unguyen7@jh.edu::92021b55-417f-458a-90a7-cf14ced67da3" providerId="AD" clId="Web-{1C5DA43F-1144-560B-A996-9F9957834AF2}" dt="2026-05-03T00:49:00.532" v="72" actId="20577"/>
+        <pc:sldMkLst>
+          <pc:docMk/>
+          <pc:sldMk cId="1284274485" sldId="259"/>
+        </pc:sldMkLst>
+        <pc:spChg chg="mod">
+          <ac:chgData name="Uyen P. Nguyen" userId="S::unguyen7@jh.edu::92021b55-417f-458a-90a7-cf14ced67da3" providerId="AD" clId="Web-{1C5DA43F-1144-560B-A996-9F9957834AF2}" dt="2026-05-03T00:49:00.532" v="72" actId="20577"/>
+          <ac:spMkLst>
+            <pc:docMk/>
+            <pc:sldMk cId="1284274485" sldId="259"/>
+            <ac:spMk id="7" creationId="{32741F24-76C7-9C01-1DBD-5EE3762FAACA}"/>
+          </ac:spMkLst>
+        </pc:spChg>
+      </pc:sldChg>
+      <pc:sldChg chg="modSp">
+        <pc:chgData name="Uyen P. Nguyen" userId="S::unguyen7@jh.edu::92021b55-417f-458a-90a7-cf14ced67da3" providerId="AD" clId="Web-{1C5DA43F-1144-560B-A996-9F9957834AF2}" dt="2026-05-03T00:48:55.797" v="67" actId="20577"/>
+        <pc:sldMkLst>
+          <pc:docMk/>
+          <pc:sldMk cId="1027488440" sldId="260"/>
+        </pc:sldMkLst>
+        <pc:spChg chg="mod">
+          <ac:chgData name="Uyen P. Nguyen" userId="S::unguyen7@jh.edu::92021b55-417f-458a-90a7-cf14ced67da3" providerId="AD" clId="Web-{1C5DA43F-1144-560B-A996-9F9957834AF2}" dt="2026-05-03T00:48:55.797" v="67" actId="20577"/>
+          <ac:spMkLst>
+            <pc:docMk/>
+            <pc:sldMk cId="1027488440" sldId="260"/>
+            <ac:spMk id="7" creationId="{2C42AF74-C537-A886-53B7-E8DF3240B7B7}"/>
+          </ac:spMkLst>
+        </pc:spChg>
+      </pc:sldChg>
+      <pc:sldChg chg="modSp">
+        <pc:chgData name="Uyen P. Nguyen" userId="S::unguyen7@jh.edu::92021b55-417f-458a-90a7-cf14ced67da3" providerId="AD" clId="Web-{1C5DA43F-1144-560B-A996-9F9957834AF2}" dt="2026-05-03T00:46:37.606" v="25"/>
+        <pc:sldMkLst>
+          <pc:docMk/>
+          <pc:sldMk cId="2092433718" sldId="265"/>
+        </pc:sldMkLst>
+        <pc:graphicFrameChg chg="mod modGraphic">
+          <ac:chgData name="Uyen P. Nguyen" userId="S::unguyen7@jh.edu::92021b55-417f-458a-90a7-cf14ced67da3" providerId="AD" clId="Web-{1C5DA43F-1144-560B-A996-9F9957834AF2}" dt="2026-05-03T00:46:37.606" v="25"/>
+          <ac:graphicFrameMkLst>
+            <pc:docMk/>
+            <pc:sldMk cId="2092433718" sldId="265"/>
+            <ac:graphicFrameMk id="3" creationId="{15498308-56C6-0976-7133-85BE4FA98101}"/>
+          </ac:graphicFrameMkLst>
+        </pc:graphicFrameChg>
       </pc:sldChg>
     </pc:docChg>
   </pc:docChgLst>
@@ -387,83 +465,6 @@
             <ac:picMk id="8" creationId="{B38A110A-4554-DD53-7B39-D305EC31083C}"/>
           </ac:picMkLst>
         </pc:picChg>
-      </pc:sldChg>
-    </pc:docChg>
-  </pc:docChgLst>
-  <pc:docChgLst>
-    <pc:chgData name="Uyen P. Nguyen" userId="S::unguyen7@jh.edu::92021b55-417f-458a-90a7-cf14ced67da3" providerId="AD" clId="Web-{1C5DA43F-1144-560B-A996-9F9957834AF2}"/>
-    <pc:docChg chg="modSld">
-      <pc:chgData name="Uyen P. Nguyen" userId="S::unguyen7@jh.edu::92021b55-417f-458a-90a7-cf14ced67da3" providerId="AD" clId="Web-{1C5DA43F-1144-560B-A996-9F9957834AF2}" dt="2026-05-03T01:28:46.789" v="180" actId="20577"/>
-      <pc:docMkLst>
-        <pc:docMk/>
-      </pc:docMkLst>
-      <pc:sldChg chg="modSp">
-        <pc:chgData name="Uyen P. Nguyen" userId="S::unguyen7@jh.edu::92021b55-417f-458a-90a7-cf14ced67da3" providerId="AD" clId="Web-{1C5DA43F-1144-560B-A996-9F9957834AF2}" dt="2026-05-03T01:28:46.789" v="180" actId="20577"/>
-        <pc:sldMkLst>
-          <pc:docMk/>
-          <pc:sldMk cId="2133178391" sldId="257"/>
-        </pc:sldMkLst>
-        <pc:spChg chg="mod">
-          <ac:chgData name="Uyen P. Nguyen" userId="S::unguyen7@jh.edu::92021b55-417f-458a-90a7-cf14ced67da3" providerId="AD" clId="Web-{1C5DA43F-1144-560B-A996-9F9957834AF2}" dt="2026-05-03T00:49:04.439" v="76" actId="20577"/>
-          <ac:spMkLst>
-            <pc:docMk/>
-            <pc:sldMk cId="2133178391" sldId="257"/>
-            <ac:spMk id="7" creationId="{D159B653-A360-6E33-D2F6-A0D58B9935A5}"/>
-          </ac:spMkLst>
-        </pc:spChg>
-        <pc:spChg chg="mod">
-          <ac:chgData name="Uyen P. Nguyen" userId="S::unguyen7@jh.edu::92021b55-417f-458a-90a7-cf14ced67da3" providerId="AD" clId="Web-{1C5DA43F-1144-560B-A996-9F9957834AF2}" dt="2026-05-03T01:28:46.789" v="180" actId="20577"/>
-          <ac:spMkLst>
-            <pc:docMk/>
-            <pc:sldMk cId="2133178391" sldId="257"/>
-            <ac:spMk id="9" creationId="{EABC739E-24F8-66FD-A37D-4CF4952DF00F}"/>
-          </ac:spMkLst>
-        </pc:spChg>
-      </pc:sldChg>
-      <pc:sldChg chg="modSp">
-        <pc:chgData name="Uyen P. Nguyen" userId="S::unguyen7@jh.edu::92021b55-417f-458a-90a7-cf14ced67da3" providerId="AD" clId="Web-{1C5DA43F-1144-560B-A996-9F9957834AF2}" dt="2026-05-03T00:49:00.532" v="72" actId="20577"/>
-        <pc:sldMkLst>
-          <pc:docMk/>
-          <pc:sldMk cId="1284274485" sldId="259"/>
-        </pc:sldMkLst>
-        <pc:spChg chg="mod">
-          <ac:chgData name="Uyen P. Nguyen" userId="S::unguyen7@jh.edu::92021b55-417f-458a-90a7-cf14ced67da3" providerId="AD" clId="Web-{1C5DA43F-1144-560B-A996-9F9957834AF2}" dt="2026-05-03T00:49:00.532" v="72" actId="20577"/>
-          <ac:spMkLst>
-            <pc:docMk/>
-            <pc:sldMk cId="1284274485" sldId="259"/>
-            <ac:spMk id="7" creationId="{32741F24-76C7-9C01-1DBD-5EE3762FAACA}"/>
-          </ac:spMkLst>
-        </pc:spChg>
-      </pc:sldChg>
-      <pc:sldChg chg="modSp">
-        <pc:chgData name="Uyen P. Nguyen" userId="S::unguyen7@jh.edu::92021b55-417f-458a-90a7-cf14ced67da3" providerId="AD" clId="Web-{1C5DA43F-1144-560B-A996-9F9957834AF2}" dt="2026-05-03T00:48:55.797" v="67" actId="20577"/>
-        <pc:sldMkLst>
-          <pc:docMk/>
-          <pc:sldMk cId="1027488440" sldId="260"/>
-        </pc:sldMkLst>
-        <pc:spChg chg="mod">
-          <ac:chgData name="Uyen P. Nguyen" userId="S::unguyen7@jh.edu::92021b55-417f-458a-90a7-cf14ced67da3" providerId="AD" clId="Web-{1C5DA43F-1144-560B-A996-9F9957834AF2}" dt="2026-05-03T00:48:55.797" v="67" actId="20577"/>
-          <ac:spMkLst>
-            <pc:docMk/>
-            <pc:sldMk cId="1027488440" sldId="260"/>
-            <ac:spMk id="7" creationId="{2C42AF74-C537-A886-53B7-E8DF3240B7B7}"/>
-          </ac:spMkLst>
-        </pc:spChg>
-      </pc:sldChg>
-      <pc:sldChg chg="modSp">
-        <pc:chgData name="Uyen P. Nguyen" userId="S::unguyen7@jh.edu::92021b55-417f-458a-90a7-cf14ced67da3" providerId="AD" clId="Web-{1C5DA43F-1144-560B-A996-9F9957834AF2}" dt="2026-05-03T00:46:37.606" v="25"/>
-        <pc:sldMkLst>
-          <pc:docMk/>
-          <pc:sldMk cId="2092433718" sldId="265"/>
-        </pc:sldMkLst>
-        <pc:graphicFrameChg chg="mod modGraphic">
-          <ac:chgData name="Uyen P. Nguyen" userId="S::unguyen7@jh.edu::92021b55-417f-458a-90a7-cf14ced67da3" providerId="AD" clId="Web-{1C5DA43F-1144-560B-A996-9F9957834AF2}" dt="2026-05-03T00:46:37.606" v="25"/>
-          <ac:graphicFrameMkLst>
-            <pc:docMk/>
-            <pc:sldMk cId="2092433718" sldId="265"/>
-            <ac:graphicFrameMk id="3" creationId="{15498308-56C6-0976-7133-85BE4FA98101}"/>
-          </ac:graphicFrameMkLst>
-        </pc:graphicFrameChg>
       </pc:sldChg>
     </pc:docChg>
   </pc:docChgLst>
@@ -4476,8 +4477,8 @@
           </a:p>
         </p:txBody>
       </p:sp>
-      <mc:AlternateContent xmlns:mc="http://schemas.openxmlformats.org/markup-compatibility/2006" xmlns:a14="http://schemas.microsoft.com/office/drawing/2010/main">
-        <mc:Choice Requires="a14">
+      <mc:AlternateContent xmlns:mc="http://schemas.openxmlformats.org/markup-compatibility/2006">
+        <mc:Choice xmlns:a14="http://schemas.microsoft.com/office/drawing/2010/main" Requires="a14">
           <p:sp>
             <p:nvSpPr>
               <p:cNvPr id="9" name="TextBox 8">
@@ -4543,7 +4544,7 @@
                     <a:ea typeface="Calibri"/>
                     <a:cs typeface="Calibri"/>
                   </a:rPr>
-                  <a:t>Cascade Procedure</a:t>
+                  <a:t>Cascade Procedure [1]</a:t>
                 </a:r>
               </a:p>
               <a:p>
@@ -4824,7 +4825,7 @@
             </p:txBody>
           </p:sp>
         </mc:Choice>
-        <mc:Fallback xmlns="">
+        <mc:Fallback>
           <p:sp>
             <p:nvSpPr>
               <p:cNvPr id="9" name="TextBox 8">
@@ -4989,8 +4990,8 @@
           </a:p>
         </p:txBody>
       </p:sp>
-      <mc:AlternateContent xmlns:mc="http://schemas.openxmlformats.org/markup-compatibility/2006" xmlns:a14="http://schemas.microsoft.com/office/drawing/2010/main">
-        <mc:Choice Requires="a14">
+      <mc:AlternateContent xmlns:mc="http://schemas.openxmlformats.org/markup-compatibility/2006">
+        <mc:Choice xmlns:a14="http://schemas.microsoft.com/office/drawing/2010/main" Requires="a14">
           <p:sp>
             <p:nvSpPr>
               <p:cNvPr id="9" name="TextBox 8">
@@ -5058,7 +5059,7 @@
                 </a:r>
                 <a:r>
                   <a:rPr lang="en-US" dirty="0"/>
-                  <a:t>bit string to maximize entropy</a:t>
+                  <a:t>bit string to maximize entropy [2]</a:t>
                 </a:r>
               </a:p>
               <a:p>
@@ -5369,14 +5370,14 @@
                     <a:ea typeface="+mn-lt"/>
                     <a:cs typeface="+mn-lt"/>
                   </a:rPr>
-                  <a:t>Key:  11110111001101011111011010111100</a:t>
+                  <a:t>Key (bit string shared by Alice and Bob):  11110111001101011111011010111100</a:t>
                 </a:r>
               </a:p>
               <a:p>
                 <a:pPr lvl="2"/>
                 <a:r>
                   <a:rPr lang="en-US" dirty="0"/>
-                  <a:t>Cipher Text: 11001111101011000101001111011001</a:t>
+                  <a:t>Cipher Text (bit string encryption of “BB84” by Alice): 11001111101011000101001111011001</a:t>
                 </a:r>
               </a:p>
               <a:p>
@@ -5386,7 +5387,7 @@
                     <a:ea typeface="Calibri" panose="020F0502020204030204"/>
                     <a:cs typeface="Calibri" panose="020F0502020204030204"/>
                   </a:rPr>
-                  <a:t>Decoded: </a:t>
+                  <a:t>Decoded (bit string decryption of cipher by Bob): </a:t>
                 </a:r>
                 <a:r>
                   <a:rPr lang="en-US" dirty="0">
@@ -5400,7 +5401,7 @@
             </p:txBody>
           </p:sp>
         </mc:Choice>
-        <mc:Fallback xmlns="">
+        <mc:Fallback>
           <p:sp>
             <p:nvSpPr>
               <p:cNvPr id="9" name="TextBox 8">
@@ -5582,7 +5583,7 @@
             <p:spPr>
               <a:xfrm>
                 <a:off x="457200" y="1181100"/>
-                <a:ext cx="10590028" cy="3785652"/>
+                <a:ext cx="10590028" cy="4093428"/>
               </a:xfrm>
               <a:prstGeom prst="rect">
                 <a:avLst/>
@@ -5667,7 +5668,7 @@
                         <a:latin typeface="Cambria Math" panose="02040503050406030204" pitchFamily="18" charset="0"/>
                         <a:cs typeface="Calibri" panose="020F0502020204030204" pitchFamily="34" charset="0"/>
                       </a:rPr>
-                      <m:t>&lt;11%</m:t>
+                      <m:t>&lt;11% </m:t>
                     </m:r>
                   </m:oMath>
                 </a14:m>
@@ -5679,7 +5680,7 @@
                     <a:latin typeface="Calibri" panose="020F0502020204030204" pitchFamily="34" charset="0"/>
                     <a:cs typeface="Calibri" panose="020F0502020204030204" pitchFamily="34" charset="0"/>
                   </a:rPr>
-                  <a:t>)</a:t>
+                  <a:t>[3])</a:t>
                 </a:r>
               </a:p>
               <a:p>
@@ -5776,7 +5777,7 @@
                     <a:ea typeface="Calibri"/>
                     <a:cs typeface="Calibri" panose="020F0502020204030204" pitchFamily="34" charset="0"/>
                   </a:rPr>
-                  <a:t>Cascade protocol can be replaced with a low-density parity check (LDPC) protocol to improve reconciliation efficiency</a:t>
+                  <a:t>Cascade protocol can be replaced with a low-density parity check (LDPC) protocol to improve reconciliation efficiency [4]</a:t>
                 </a:r>
               </a:p>
               <a:p>
@@ -5796,29 +5797,7 @@
                     <a:ea typeface="Calibri"/>
                     <a:cs typeface="Calibri" panose="020F0502020204030204" pitchFamily="34" charset="0"/>
                   </a:rPr>
-                  <a:t>Later QKD protocols such as </a:t>
-                </a:r>
-                <a:r>
-                  <a:rPr lang="en-US" sz="2000">
-                    <a:solidFill>
-                      <a:srgbClr val="202123"/>
-                    </a:solidFill>
-                    <a:latin typeface="Calibri" panose="020F0502020204030204" pitchFamily="34" charset="0"/>
-                    <a:ea typeface="Calibri"/>
-                    <a:cs typeface="Calibri" panose="020F0502020204030204" pitchFamily="34" charset="0"/>
-                  </a:rPr>
-                  <a:t>E91 uses </a:t>
-                </a:r>
-                <a:r>
-                  <a:rPr lang="en-US" sz="2000" dirty="0">
-                    <a:solidFill>
-                      <a:srgbClr val="202123"/>
-                    </a:solidFill>
-                    <a:latin typeface="Calibri" panose="020F0502020204030204" pitchFamily="34" charset="0"/>
-                    <a:ea typeface="Calibri"/>
-                    <a:cs typeface="Calibri" panose="020F0502020204030204" pitchFamily="34" charset="0"/>
-                  </a:rPr>
-                  <a:t>entanglement to provide device-independent security</a:t>
+                  <a:t>Later QKD protocols such as E91 uses entanglement to provide device-independent security [5]</a:t>
                 </a:r>
               </a:p>
             </p:txBody>
@@ -5842,7 +5821,7 @@
             <p:spPr>
               <a:xfrm>
                 <a:off x="457200" y="1181100"/>
-                <a:ext cx="10590028" cy="3785652"/>
+                <a:ext cx="10590028" cy="4093428"/>
               </a:xfrm>
               <a:prstGeom prst="rect">
                 <a:avLst/>
@@ -5850,7 +5829,7 @@
               <a:blipFill>
                 <a:blip r:embed="rId2"/>
                 <a:stretch>
-                  <a:fillRect l="-518" t="-966" r="-230" b="-1932"/>
+                  <a:fillRect l="-518" t="-894" r="-230" b="-1788"/>
                 </a:stretch>
               </a:blipFill>
             </p:spPr>
@@ -5890,7 +5869,7 @@
         <p:cNvPr id="1" name="">
           <a:extLst>
             <a:ext uri="{FF2B5EF4-FFF2-40B4-BE49-F238E27FC236}">
-              <a16:creationId xmlns:a16="http://schemas.microsoft.com/office/drawing/2014/main" id="{2AC4A3D5-C1C1-2131-970F-D325EBE3F643}"/>
+              <a16:creationId xmlns:a16="http://schemas.microsoft.com/office/drawing/2014/main" id="{B6BBCB00-2422-1CCD-376A-DA9BFEE5784D}"/>
             </a:ext>
           </a:extLst>
         </p:cNvPr>
@@ -5910,7 +5889,7 @@
           <p:cNvPr id="7" name="Title 1">
             <a:extLst>
               <a:ext uri="{FF2B5EF4-FFF2-40B4-BE49-F238E27FC236}">
-                <a16:creationId xmlns:a16="http://schemas.microsoft.com/office/drawing/2014/main" id="{7400B334-7665-58DA-2250-9B9D61176C73}"/>
+                <a16:creationId xmlns:a16="http://schemas.microsoft.com/office/drawing/2014/main" id="{90A989AD-B9F0-9CCD-E295-6B689EE9CA05}"/>
               </a:ext>
             </a:extLst>
           </p:cNvPr>
@@ -5970,6 +5949,251 @@
               <a:defRPr/>
             </a:pPr>
             <a:r>
+              <a:rPr kumimoji="0" lang="en-US" sz="3600" b="1" i="0" u="none" strike="noStrike" kern="1200" cap="none" spc="0" normalizeH="0" baseline="0" noProof="0" dirty="0" err="1">
+                <a:ln>
+                  <a:noFill/>
+                </a:ln>
+                <a:solidFill>
+                  <a:srgbClr val="002C73"/>
+                </a:solidFill>
+                <a:effectLst/>
+                <a:uLnTx/>
+                <a:uFillTx/>
+                <a:latin typeface="Arial" panose="020B0604020202020204"/>
+                <a:ea typeface="+mj-ea"/>
+                <a:cs typeface="+mj-cs"/>
+              </a:rPr>
+              <a:t>Referenes</a:t>
+            </a:r>
+            <a:endParaRPr kumimoji="0" lang="en-US" sz="3600" b="1" i="0" u="none" strike="noStrike" kern="1200" cap="none" spc="0" normalizeH="0" baseline="0" noProof="0" dirty="0">
+              <a:ln>
+                <a:noFill/>
+              </a:ln>
+              <a:solidFill>
+                <a:srgbClr val="002C73"/>
+              </a:solidFill>
+              <a:effectLst/>
+              <a:uLnTx/>
+              <a:uFillTx/>
+              <a:latin typeface="Arial" panose="020B0604020202020204"/>
+              <a:ea typeface="+mj-ea"/>
+              <a:cs typeface="+mj-cs"/>
+            </a:endParaRPr>
+          </a:p>
+        </p:txBody>
+      </p:sp>
+      <p:sp>
+        <p:nvSpPr>
+          <p:cNvPr id="9" name="TextBox 8">
+            <a:extLst>
+              <a:ext uri="{FF2B5EF4-FFF2-40B4-BE49-F238E27FC236}">
+                <a16:creationId xmlns:a16="http://schemas.microsoft.com/office/drawing/2014/main" id="{C89F4900-C9E0-428B-42D2-0030EA9D93D9}"/>
+              </a:ext>
+            </a:extLst>
+          </p:cNvPr>
+          <p:cNvSpPr txBox="1"/>
+          <p:nvPr/>
+        </p:nvSpPr>
+        <p:spPr>
+          <a:xfrm>
+            <a:off x="457200" y="1143350"/>
+            <a:ext cx="10590028" cy="4093428"/>
+          </a:xfrm>
+          <a:prstGeom prst="rect">
+            <a:avLst/>
+          </a:prstGeom>
+          <a:noFill/>
+        </p:spPr>
+        <p:txBody>
+          <a:bodyPr wrap="square" lIns="91440" tIns="45720" rIns="91440" bIns="45720" anchor="t">
+            <a:spAutoFit/>
+          </a:bodyPr>
+          <a:lstStyle/>
+          <a:p>
+            <a:pPr marL="457200" indent="-457200">
+              <a:buFont typeface="+mj-lt"/>
+              <a:buAutoNum type="arabicPeriod"/>
+            </a:pPr>
+            <a:r>
+              <a:rPr lang="en-US" sz="2000" dirty="0"/>
+              <a:t>G. Brassard and L. Salvail, ‘‘Secret-key reconciliation by public dis </a:t>
+            </a:r>
+            <a:r>
+              <a:rPr lang="en-US" sz="2000" dirty="0" err="1"/>
+              <a:t>cussion</a:t>
+            </a:r>
+            <a:r>
+              <a:rPr lang="en-US" sz="2000" dirty="0"/>
+              <a:t>,’’ in Advances in Cryptology—EUROCRYPT (Lecture Notes in Computer Science), T. </a:t>
+            </a:r>
+            <a:r>
+              <a:rPr lang="en-US" sz="2000" dirty="0" err="1"/>
+              <a:t>Helleseth</a:t>
+            </a:r>
+            <a:r>
+              <a:rPr lang="en-US" sz="2000" dirty="0"/>
+              <a:t>, Ed. vol. 765. Berlin, Germany: Springer, 1994.</a:t>
+            </a:r>
+          </a:p>
+          <a:p>
+            <a:pPr marL="457200" indent="-457200">
+              <a:buFont typeface="+mj-lt"/>
+              <a:buAutoNum type="arabicPeriod"/>
+            </a:pPr>
+            <a:r>
+              <a:rPr lang="en-US" sz="2000" dirty="0"/>
+              <a:t>C. H. Bennett, G. Brassard, and J.-M. Robert, “Privacy amplification by public discussion,” SIAM Journal on Computing, vol. 17, no. 2, pp. 210–229, 1988. [Online]. Available: https://doi.org/10.1137/0217014</a:t>
+            </a:r>
+          </a:p>
+          <a:p>
+            <a:pPr marL="457200" indent="-457200">
+              <a:buFont typeface="+mj-lt"/>
+              <a:buAutoNum type="arabicPeriod"/>
+            </a:pPr>
+            <a:r>
+              <a:rPr lang="en-US" sz="2000" dirty="0"/>
+              <a:t>P. W. Shor and J. </a:t>
+            </a:r>
+            <a:r>
+              <a:rPr lang="en-US" sz="2000" dirty="0" err="1"/>
+              <a:t>Preskill</a:t>
+            </a:r>
+            <a:r>
+              <a:rPr lang="en-US" sz="2000" dirty="0"/>
+              <a:t>, “Simple proof of security of the bb84 quantum key distribution protocol,” Physical Review Letters, vol. 85, no. 2, p. 441–444, 2000. [Online]. Available: http: //dx.doi.org/10.1103/PhysRevLett.85.441</a:t>
+            </a:r>
+          </a:p>
+          <a:p>
+            <a:pPr marL="457200" indent="-457200">
+              <a:buFont typeface="+mj-lt"/>
+              <a:buAutoNum type="arabicPeriod"/>
+            </a:pPr>
+            <a:r>
+              <a:rPr lang="en-US" sz="2000" dirty="0"/>
+              <a:t>Elkouss, David, Jesús Martínez-Mateo, and Vicente Martín. "Information Reconciliation for Quantum Key Distribution Using Low-Density Parity-Check Codes," 2009.</a:t>
+            </a:r>
+          </a:p>
+          <a:p>
+            <a:pPr marL="457200" indent="-457200">
+              <a:buFont typeface="+mj-lt"/>
+              <a:buAutoNum type="arabicPeriod"/>
+            </a:pPr>
+            <a:r>
+              <a:rPr lang="en-US" sz="2000" dirty="0"/>
+              <a:t>M. A. Nielsen and I. L. Chuang, “Quantum Computation and Quan-tum Information: 10th Anniversary Edition”. Cambridge: </a:t>
+            </a:r>
+            <a:r>
+              <a:rPr lang="en-US" sz="2000" dirty="0" err="1"/>
+              <a:t>CambridgeUniversity</a:t>
+            </a:r>
+            <a:r>
+              <a:rPr lang="en-US" sz="2000" dirty="0"/>
+              <a:t> Press, 2010.</a:t>
+            </a:r>
+          </a:p>
+        </p:txBody>
+      </p:sp>
+    </p:spTree>
+    <p:extLst>
+      <p:ext uri="{BB962C8B-B14F-4D97-AF65-F5344CB8AC3E}">
+        <p14:creationId xmlns:p14="http://schemas.microsoft.com/office/powerpoint/2010/main" val="105113814"/>
+      </p:ext>
+    </p:extLst>
+  </p:cSld>
+  <p:clrMapOvr>
+    <a:masterClrMapping/>
+  </p:clrMapOvr>
+</p:sld>
+</file>
+
+<file path=ppt/slides/slide14.xml><?xml version="1.0" encoding="utf-8"?>
+<p:sld xmlns:a="http://schemas.openxmlformats.org/drawingml/2006/main" xmlns:r="http://schemas.openxmlformats.org/officeDocument/2006/relationships" xmlns:p="http://schemas.openxmlformats.org/presentationml/2006/main">
+  <p:cSld>
+    <p:spTree>
+      <p:nvGrpSpPr>
+        <p:cNvPr id="1" name="">
+          <a:extLst>
+            <a:ext uri="{FF2B5EF4-FFF2-40B4-BE49-F238E27FC236}">
+              <a16:creationId xmlns:a16="http://schemas.microsoft.com/office/drawing/2014/main" id="{2AC4A3D5-C1C1-2131-970F-D325EBE3F643}"/>
+            </a:ext>
+          </a:extLst>
+        </p:cNvPr>
+        <p:cNvGrpSpPr/>
+        <p:nvPr/>
+      </p:nvGrpSpPr>
+      <p:grpSpPr>
+        <a:xfrm>
+          <a:off x="0" y="0"/>
+          <a:ext cx="0" cy="0"/>
+          <a:chOff x="0" y="0"/>
+          <a:chExt cx="0" cy="0"/>
+        </a:xfrm>
+      </p:grpSpPr>
+      <p:sp>
+        <p:nvSpPr>
+          <p:cNvPr id="7" name="Title 1">
+            <a:extLst>
+              <a:ext uri="{FF2B5EF4-FFF2-40B4-BE49-F238E27FC236}">
+                <a16:creationId xmlns:a16="http://schemas.microsoft.com/office/drawing/2014/main" id="{7400B334-7665-58DA-2250-9B9D61176C73}"/>
+              </a:ext>
+            </a:extLst>
+          </p:cNvPr>
+          <p:cNvSpPr txBox="1">
+            <a:spLocks/>
+          </p:cNvSpPr>
+          <p:nvPr/>
+        </p:nvSpPr>
+        <p:spPr>
+          <a:xfrm>
+            <a:off x="457200" y="419100"/>
+            <a:ext cx="11277600" cy="762000"/>
+          </a:xfrm>
+          <a:prstGeom prst="rect">
+            <a:avLst/>
+          </a:prstGeom>
+        </p:spPr>
+        <p:txBody>
+          <a:bodyPr vert="horz" lIns="0" tIns="0" rIns="0" bIns="0" rtlCol="0" anchor="t" anchorCtr="0">
+            <a:normAutofit/>
+          </a:bodyPr>
+          <a:lstStyle>
+            <a:lvl1pPr algn="l" defTabSz="914400" rtl="0" eaLnBrk="1" latinLnBrk="0" hangingPunct="1">
+              <a:lnSpc>
+                <a:spcPct val="90000"/>
+              </a:lnSpc>
+              <a:spcBef>
+                <a:spcPct val="0"/>
+              </a:spcBef>
+              <a:buNone/>
+              <a:defRPr sz="3600" b="1" kern="1200" baseline="0">
+                <a:solidFill>
+                  <a:schemeClr val="accent1"/>
+                </a:solidFill>
+                <a:latin typeface="+mj-lt"/>
+                <a:ea typeface="+mj-ea"/>
+                <a:cs typeface="+mj-cs"/>
+              </a:defRPr>
+            </a:lvl1pPr>
+          </a:lstStyle>
+          <a:p>
+            <a:pPr marL="0" marR="0" lvl="0" indent="0" algn="l" defTabSz="914400" rtl="0" eaLnBrk="1" fontAlgn="auto" latinLnBrk="0" hangingPunct="1">
+              <a:lnSpc>
+                <a:spcPct val="90000"/>
+              </a:lnSpc>
+              <a:spcBef>
+                <a:spcPct val="0"/>
+              </a:spcBef>
+              <a:spcAft>
+                <a:spcPts val="0"/>
+              </a:spcAft>
+              <a:buClrTx/>
+              <a:buSzTx/>
+              <a:buFontTx/>
+              <a:buNone/>
+              <a:tabLst/>
+              <a:defRPr/>
+            </a:pPr>
+            <a:r>
               <a:rPr kumimoji="0" lang="en-US" sz="3600" b="1" i="0" u="none" strike="noStrike" kern="1200" cap="none" spc="0" normalizeH="0" baseline="0" noProof="0">
                 <a:ln>
                   <a:noFill/>
@@ -6022,7 +6246,7 @@
               <a:buChar char="•"/>
             </a:pPr>
             <a:r>
-              <a:rPr lang="en-US" sz="2000">
+              <a:rPr lang="en-US" sz="2000" dirty="0">
                 <a:latin typeface="Calibri"/>
                 <a:ea typeface="Calibri"/>
                 <a:cs typeface="Calibri"/>
@@ -6036,7 +6260,7 @@
               <a:buChar char="o"/>
             </a:pPr>
             <a:r>
-              <a:rPr lang="en-US" sz="2000">
+              <a:rPr lang="en-US" sz="2000" dirty="0">
                 <a:latin typeface="Calibri" panose="020F0502020204030204" pitchFamily="34" charset="0"/>
                 <a:cs typeface="Calibri" panose="020F0502020204030204" pitchFamily="34" charset="0"/>
               </a:rPr>
@@ -6052,17 +6276,30 @@
               <a:buChar char="o"/>
             </a:pPr>
             <a:r>
-              <a:rPr lang="en-US" sz="2000">
+              <a:rPr lang="en-US" sz="2000" dirty="0">
                 <a:latin typeface="Calibri"/>
                 <a:ea typeface="Calibri"/>
                 <a:cs typeface="Calibri"/>
               </a:rPr>
-              <a:t>Implemented code in Qiskit</a:t>
-            </a:r>
+              <a:t>Implemented code in </a:t>
+            </a:r>
+            <a:r>
+              <a:rPr lang="en-US" sz="2000" dirty="0" err="1">
+                <a:latin typeface="Calibri"/>
+                <a:ea typeface="Calibri"/>
+                <a:cs typeface="Calibri"/>
+              </a:rPr>
+              <a:t>Qiskit</a:t>
+            </a:r>
+            <a:endParaRPr lang="en-US" sz="2000" dirty="0">
+              <a:latin typeface="Calibri"/>
+              <a:ea typeface="Calibri"/>
+              <a:cs typeface="Calibri"/>
+            </a:endParaRPr>
           </a:p>
           <a:p>
             <a:pPr lvl="1"/>
-            <a:endParaRPr lang="en-US" sz="2000">
+            <a:endParaRPr lang="en-US" sz="2000" dirty="0">
               <a:latin typeface="Calibri" panose="020F0502020204030204" pitchFamily="34" charset="0"/>
               <a:ea typeface="Calibri"/>
               <a:cs typeface="Calibri" panose="020F0502020204030204" pitchFamily="34" charset="0"/>
@@ -6572,7 +6809,7 @@
 </p:sld>
 </file>
 
-<file path=ppt/slides/slide14.xml><?xml version="1.0" encoding="utf-8"?>
+<file path=ppt/slides/slide15.xml><?xml version="1.0" encoding="utf-8"?>
 <p:sld xmlns:a="http://schemas.openxmlformats.org/drawingml/2006/main" xmlns:r="http://schemas.openxmlformats.org/officeDocument/2006/relationships" xmlns:p="http://schemas.openxmlformats.org/presentationml/2006/main">
   <p:cSld>
     <p:spTree>

</xml_diff>